<commit_message>
Updated Stacks Lab 2 ppt
</commit_message>
<xml_diff>
--- a/u06b_stacks/notes/13b.expressionTester.pptx
+++ b/u06b_stacks/notes/13b.expressionTester.pptx
@@ -5,10 +5,10 @@
     <p:sldMasterId id="2147483648" r:id="rId1"/>
   </p:sldMasterIdLst>
   <p:notesMasterIdLst>
-    <p:notesMasterId r:id="rId18"/>
+    <p:notesMasterId r:id="rId19"/>
   </p:notesMasterIdLst>
   <p:handoutMasterIdLst>
-    <p:handoutMasterId r:id="rId19"/>
+    <p:handoutMasterId r:id="rId20"/>
   </p:handoutMasterIdLst>
   <p:sldIdLst>
     <p:sldId id="385" r:id="rId2"/>
@@ -27,6 +27,7 @@
     <p:sldId id="411" r:id="rId15"/>
     <p:sldId id="412" r:id="rId16"/>
     <p:sldId id="413" r:id="rId17"/>
+    <p:sldId id="414" r:id="rId18"/>
   </p:sldIdLst>
   <p:sldSz cx="9144000" cy="6858000" type="screen4x3"/>
   <p:notesSz cx="6858000" cy="9144000"/>
@@ -9992,8 +9993,8 @@
         </p:nvSpPr>
         <p:spPr>
           <a:xfrm>
-            <a:off x="266700" y="1398925"/>
-            <a:ext cx="8610600" cy="3477875"/>
+            <a:off x="266700" y="1371600"/>
+            <a:ext cx="8610600" cy="1569660"/>
           </a:xfrm>
           <a:prstGeom prst="rect">
             <a:avLst/>
@@ -10007,7 +10008,7 @@
           <a:lstStyle/>
           <a:p>
             <a:r>
-              <a:rPr lang="en-US" sz="2200" dirty="0">
+              <a:rPr lang="en-US" sz="2400" dirty="0">
                 <a:solidFill>
                   <a:srgbClr val="941EDF"/>
                 </a:solidFill>
@@ -10016,7 +10017,7 @@
               <a:t>public</a:t>
             </a:r>
             <a:r>
-              <a:rPr lang="en-US" sz="2200" dirty="0">
+              <a:rPr lang="en-US" sz="2400" dirty="0">
                 <a:solidFill>
                   <a:srgbClr val="000000"/>
                 </a:solidFill>
@@ -10025,7 +10026,7 @@
               <a:t> </a:t>
             </a:r>
             <a:r>
-              <a:rPr lang="en-US" sz="2200" dirty="0" err="1">
+              <a:rPr lang="en-US" sz="2400" dirty="0" err="1">
                 <a:solidFill>
                   <a:srgbClr val="941EDF"/>
                 </a:solidFill>
@@ -10034,7 +10035,7 @@
               <a:t>boolean</a:t>
             </a:r>
             <a:r>
-              <a:rPr lang="en-US" sz="2200" dirty="0">
+              <a:rPr lang="en-US" sz="2400" dirty="0">
                 <a:solidFill>
                   <a:srgbClr val="000000"/>
                 </a:solidFill>
@@ -10043,7 +10044,7 @@
               <a:t> </a:t>
             </a:r>
             <a:r>
-              <a:rPr lang="en-US" sz="2200" dirty="0" err="1">
+              <a:rPr lang="en-US" sz="2400" dirty="0" err="1">
                 <a:solidFill>
                   <a:srgbClr val="000000"/>
                 </a:solidFill>
@@ -10052,7 +10053,7 @@
               <a:t>checkExpression</a:t>
             </a:r>
             <a:r>
-              <a:rPr lang="en-US" sz="2200" dirty="0">
+              <a:rPr lang="en-US" sz="2400" dirty="0">
                 <a:solidFill>
                   <a:srgbClr val="000000"/>
                 </a:solidFill>
@@ -10061,7 +10062,7 @@
               <a:t>() {</a:t>
             </a:r>
             <a:br>
-              <a:rPr lang="en-US" sz="2200" dirty="0">
+              <a:rPr lang="en-US" sz="2400" dirty="0">
                 <a:solidFill>
                   <a:srgbClr val="000000"/>
                 </a:solidFill>
@@ -10069,376 +10070,79 @@
               </a:rPr>
             </a:br>
             <a:r>
-              <a:rPr lang="en-US" sz="2200" dirty="0">
+              <a:rPr lang="en-US" sz="2400" dirty="0">
                 <a:solidFill>
                   <a:srgbClr val="000000"/>
                 </a:solidFill>
                 <a:latin typeface="Courier New" panose="02070309020205020404" pitchFamily="49" charset="0"/>
               </a:rPr>
-              <a:t>   Stack&lt;String&gt; symbols;</a:t>
-            </a:r>
-          </a:p>
-          <a:p>
-            <a:r>
-              <a:rPr lang="en-US" sz="2200" dirty="0">
+              <a:t>   Stack&lt;String&gt; stack = </a:t>
+            </a:r>
+            <a:r>
+              <a:rPr lang="en-US" sz="2400" dirty="0">
+                <a:solidFill>
+                  <a:srgbClr val="941EDF"/>
+                </a:solidFill>
+                <a:latin typeface="Courier New" panose="02070309020205020404" pitchFamily="49" charset="0"/>
+              </a:rPr>
+              <a:t>new</a:t>
+            </a:r>
+            <a:r>
+              <a:rPr lang="en-US" sz="2400" dirty="0">
                 <a:solidFill>
                   <a:srgbClr val="000000"/>
                 </a:solidFill>
                 <a:latin typeface="Courier New" panose="02070309020205020404" pitchFamily="49" charset="0"/>
               </a:rPr>
-              <a:t>   symbols = </a:t>
-            </a:r>
-            <a:r>
-              <a:rPr lang="en-US" sz="2200" dirty="0">
-                <a:solidFill>
-                  <a:srgbClr val="941EDF"/>
-                </a:solidFill>
-                <a:latin typeface="Courier New" panose="02070309020205020404" pitchFamily="49" charset="0"/>
-              </a:rPr>
-              <a:t>new</a:t>
-            </a:r>
-            <a:r>
-              <a:rPr lang="en-US" sz="2200" dirty="0">
+              <a:t> Stack&lt;&gt;();</a:t>
+            </a:r>
+            <a:br>
+              <a:rPr lang="en-US" sz="2400" dirty="0">
                 <a:solidFill>
                   <a:srgbClr val="000000"/>
                 </a:solidFill>
                 <a:latin typeface="Courier New" panose="02070309020205020404" pitchFamily="49" charset="0"/>
               </a:rPr>
-              <a:t> Stack&lt;String&gt;();</a:t>
+            </a:br>
+            <a:r>
+              <a:rPr lang="en-US" sz="2400" dirty="0">
+                <a:solidFill>
+                  <a:schemeClr val="accent6">
+                    <a:lumMod val="75000"/>
+                  </a:schemeClr>
+                </a:solidFill>
+                <a:latin typeface="Courier New" panose="02070309020205020404" pitchFamily="49" charset="0"/>
+              </a:rPr>
+              <a:t>   String[]   open = {"{", "(", "&lt;", "["};</a:t>
             </a:r>
             <a:br>
-              <a:rPr lang="en-US" sz="2200" dirty="0">
-                <a:solidFill>
-                  <a:srgbClr val="000000"/>
+              <a:rPr lang="en-US" sz="2400" dirty="0">
+                <a:solidFill>
+                  <a:schemeClr val="accent6">
+                    <a:lumMod val="75000"/>
+                  </a:schemeClr>
                 </a:solidFill>
                 <a:latin typeface="Courier New" panose="02070309020205020404" pitchFamily="49" charset="0"/>
               </a:rPr>
             </a:br>
             <a:r>
-              <a:rPr lang="en-US" sz="2200" dirty="0">
-                <a:solidFill>
-                  <a:srgbClr val="000000"/>
-                </a:solidFill>
-                <a:latin typeface="Courier New" panose="02070309020205020404" pitchFamily="49" charset="0"/>
-              </a:rPr>
-              <a:t>   String[]  open = {</a:t>
-            </a:r>
-            <a:r>
-              <a:rPr lang="en-US" sz="2200" dirty="0">
-                <a:solidFill>
-                  <a:srgbClr val="00A000"/>
-                </a:solidFill>
-                <a:latin typeface="Courier New" panose="02070309020205020404" pitchFamily="49" charset="0"/>
-              </a:rPr>
-              <a:t>"{"</a:t>
-            </a:r>
-            <a:r>
-              <a:rPr lang="en-US" sz="2200" dirty="0">
-                <a:solidFill>
-                  <a:srgbClr val="000000"/>
-                </a:solidFill>
-                <a:latin typeface="Courier New" panose="02070309020205020404" pitchFamily="49" charset="0"/>
-              </a:rPr>
-              <a:t>, </a:t>
-            </a:r>
-            <a:r>
-              <a:rPr lang="en-US" sz="2200" dirty="0">
-                <a:solidFill>
-                  <a:srgbClr val="00A000"/>
-                </a:solidFill>
-                <a:latin typeface="Courier New" panose="02070309020205020404" pitchFamily="49" charset="0"/>
-              </a:rPr>
-              <a:t>"("</a:t>
-            </a:r>
-            <a:r>
-              <a:rPr lang="en-US" sz="2200" dirty="0">
-                <a:solidFill>
-                  <a:srgbClr val="000000"/>
-                </a:solidFill>
-                <a:latin typeface="Courier New" panose="02070309020205020404" pitchFamily="49" charset="0"/>
-              </a:rPr>
-              <a:t>, </a:t>
-            </a:r>
-            <a:r>
-              <a:rPr lang="en-US" sz="2200" dirty="0">
-                <a:solidFill>
-                  <a:srgbClr val="00A000"/>
-                </a:solidFill>
-                <a:latin typeface="Courier New" panose="02070309020205020404" pitchFamily="49" charset="0"/>
-              </a:rPr>
-              <a:t>"&lt;"</a:t>
-            </a:r>
-            <a:r>
-              <a:rPr lang="en-US" sz="2200" dirty="0">
-                <a:solidFill>
-                  <a:srgbClr val="000000"/>
-                </a:solidFill>
-                <a:latin typeface="Courier New" panose="02070309020205020404" pitchFamily="49" charset="0"/>
-              </a:rPr>
-              <a:t>, </a:t>
-            </a:r>
-            <a:r>
-              <a:rPr lang="en-US" sz="2200" dirty="0">
-                <a:solidFill>
-                  <a:srgbClr val="00A000"/>
-                </a:solidFill>
-                <a:latin typeface="Courier New" panose="02070309020205020404" pitchFamily="49" charset="0"/>
-              </a:rPr>
-              <a:t>"["</a:t>
-            </a:r>
-            <a:r>
-              <a:rPr lang="en-US" sz="2200" dirty="0">
-                <a:solidFill>
-                  <a:srgbClr val="000000"/>
-                </a:solidFill>
-                <a:latin typeface="Courier New" panose="02070309020205020404" pitchFamily="49" charset="0"/>
-              </a:rPr>
-              <a:t>};</a:t>
-            </a:r>
-            <a:br>
-              <a:rPr lang="en-US" sz="2200" dirty="0">
-                <a:solidFill>
-                  <a:srgbClr val="000000"/>
-                </a:solidFill>
-                <a:latin typeface="Courier New" panose="02070309020205020404" pitchFamily="49" charset="0"/>
-              </a:rPr>
-            </a:br>
-            <a:r>
-              <a:rPr lang="en-US" sz="2200" dirty="0">
-                <a:solidFill>
-                  <a:srgbClr val="000000"/>
-                </a:solidFill>
-                <a:latin typeface="Courier New" panose="02070309020205020404" pitchFamily="49" charset="0"/>
-              </a:rPr>
-              <a:t>   String[] close = {</a:t>
-            </a:r>
-            <a:r>
-              <a:rPr lang="en-US" sz="2200" dirty="0">
-                <a:solidFill>
-                  <a:srgbClr val="00A000"/>
-                </a:solidFill>
-                <a:latin typeface="Courier New" panose="02070309020205020404" pitchFamily="49" charset="0"/>
-              </a:rPr>
-              <a:t>"}"</a:t>
-            </a:r>
-            <a:r>
-              <a:rPr lang="en-US" sz="2200" dirty="0">
-                <a:solidFill>
-                  <a:srgbClr val="000000"/>
-                </a:solidFill>
-                <a:latin typeface="Courier New" panose="02070309020205020404" pitchFamily="49" charset="0"/>
-              </a:rPr>
-              <a:t>, </a:t>
-            </a:r>
-            <a:r>
-              <a:rPr lang="en-US" sz="2200" dirty="0">
-                <a:solidFill>
-                  <a:srgbClr val="00A000"/>
-                </a:solidFill>
-                <a:latin typeface="Courier New" panose="02070309020205020404" pitchFamily="49" charset="0"/>
-              </a:rPr>
-              <a:t>")"</a:t>
-            </a:r>
-            <a:r>
-              <a:rPr lang="en-US" sz="2200" dirty="0">
-                <a:solidFill>
-                  <a:srgbClr val="000000"/>
-                </a:solidFill>
-                <a:latin typeface="Courier New" panose="02070309020205020404" pitchFamily="49" charset="0"/>
-              </a:rPr>
-              <a:t>, </a:t>
-            </a:r>
-            <a:r>
-              <a:rPr lang="en-US" sz="2200" dirty="0">
-                <a:solidFill>
-                  <a:srgbClr val="00A000"/>
-                </a:solidFill>
-                <a:latin typeface="Courier New" panose="02070309020205020404" pitchFamily="49" charset="0"/>
-              </a:rPr>
-              <a:t>"&gt;"</a:t>
-            </a:r>
-            <a:r>
-              <a:rPr lang="en-US" sz="2200" dirty="0">
-                <a:solidFill>
-                  <a:srgbClr val="000000"/>
-                </a:solidFill>
-                <a:latin typeface="Courier New" panose="02070309020205020404" pitchFamily="49" charset="0"/>
-              </a:rPr>
-              <a:t>, </a:t>
-            </a:r>
-            <a:r>
-              <a:rPr lang="en-US" sz="2200" dirty="0">
-                <a:solidFill>
-                  <a:srgbClr val="00A000"/>
-                </a:solidFill>
-                <a:latin typeface="Courier New" panose="02070309020205020404" pitchFamily="49" charset="0"/>
-              </a:rPr>
-              <a:t>"]"</a:t>
-            </a:r>
-            <a:r>
-              <a:rPr lang="en-US" sz="2200" dirty="0">
-                <a:solidFill>
-                  <a:srgbClr val="000000"/>
-                </a:solidFill>
-                <a:latin typeface="Courier New" panose="02070309020205020404" pitchFamily="49" charset="0"/>
-              </a:rPr>
-              <a:t>};</a:t>
-            </a:r>
-            <a:br>
-              <a:rPr lang="en-US" sz="2200" dirty="0">
-                <a:solidFill>
-                  <a:srgbClr val="000000"/>
-                </a:solidFill>
-                <a:latin typeface="Courier New" panose="02070309020205020404" pitchFamily="49" charset="0"/>
-              </a:rPr>
-            </a:br>
-            <a:br>
-              <a:rPr lang="en-US" sz="2200" dirty="0">
-                <a:solidFill>
-                  <a:srgbClr val="000000"/>
-                </a:solidFill>
-                <a:latin typeface="Courier New" panose="02070309020205020404" pitchFamily="49" charset="0"/>
-              </a:rPr>
-            </a:br>
-            <a:r>
-              <a:rPr lang="en-US" sz="2200" dirty="0">
-                <a:solidFill>
-                  <a:srgbClr val="000000"/>
-                </a:solidFill>
-                <a:latin typeface="Courier New" panose="02070309020205020404" pitchFamily="49" charset="0"/>
-              </a:rPr>
-              <a:t>   </a:t>
-            </a:r>
-            <a:r>
-              <a:rPr lang="en-US" sz="2200" dirty="0">
-                <a:solidFill>
-                  <a:srgbClr val="941EDF"/>
-                </a:solidFill>
-                <a:latin typeface="Courier New" panose="02070309020205020404" pitchFamily="49" charset="0"/>
-              </a:rPr>
-              <a:t>for</a:t>
-            </a:r>
-            <a:r>
-              <a:rPr lang="en-US" sz="2200" dirty="0">
-                <a:solidFill>
-                  <a:srgbClr val="000000"/>
-                </a:solidFill>
-                <a:latin typeface="Courier New" panose="02070309020205020404" pitchFamily="49" charset="0"/>
-              </a:rPr>
-              <a:t>(</a:t>
-            </a:r>
-            <a:r>
-              <a:rPr lang="en-US" sz="2200" dirty="0">
-                <a:solidFill>
-                  <a:srgbClr val="941EDF"/>
-                </a:solidFill>
-                <a:latin typeface="Courier New" panose="02070309020205020404" pitchFamily="49" charset="0"/>
-              </a:rPr>
-              <a:t>int</a:t>
-            </a:r>
-            <a:r>
-              <a:rPr lang="en-US" sz="2200" dirty="0">
-                <a:solidFill>
-                  <a:srgbClr val="000000"/>
-                </a:solidFill>
-                <a:latin typeface="Courier New" panose="02070309020205020404" pitchFamily="49" charset="0"/>
-              </a:rPr>
-              <a:t> i=0; i &lt; </a:t>
-            </a:r>
-            <a:r>
-              <a:rPr lang="en-US" sz="2200" dirty="0" err="1">
-                <a:solidFill>
-                  <a:srgbClr val="000000"/>
-                </a:solidFill>
-                <a:latin typeface="Courier New" panose="02070309020205020404" pitchFamily="49" charset="0"/>
-              </a:rPr>
-              <a:t>expression.length</a:t>
-            </a:r>
-            <a:r>
-              <a:rPr lang="en-US" sz="2200" dirty="0">
-                <a:solidFill>
-                  <a:srgbClr val="000000"/>
-                </a:solidFill>
-                <a:latin typeface="Courier New" panose="02070309020205020404" pitchFamily="49" charset="0"/>
-              </a:rPr>
-              <a:t>();  i++) </a:t>
-            </a:r>
-          </a:p>
-          <a:p>
-            <a:r>
-              <a:rPr lang="en-US" sz="2200" dirty="0">
-                <a:solidFill>
-                  <a:srgbClr val="000000"/>
-                </a:solidFill>
-                <a:latin typeface="Courier New" panose="02070309020205020404" pitchFamily="49" charset="0"/>
-              </a:rPr>
-              <a:t>   {</a:t>
-            </a:r>
-            <a:br>
-              <a:rPr lang="en-US" sz="2200" dirty="0">
-                <a:solidFill>
-                  <a:srgbClr val="000000"/>
-                </a:solidFill>
-                <a:latin typeface="Courier New" panose="02070309020205020404" pitchFamily="49" charset="0"/>
-              </a:rPr>
-            </a:br>
-            <a:r>
-              <a:rPr lang="en-US" sz="2200" dirty="0">
-                <a:solidFill>
-                  <a:srgbClr val="000000"/>
-                </a:solidFill>
-                <a:latin typeface="Courier New" panose="02070309020205020404" pitchFamily="49" charset="0"/>
-              </a:rPr>
-              <a:t>      String </a:t>
-            </a:r>
-            <a:r>
-              <a:rPr lang="en-US" sz="2200" dirty="0" err="1">
-                <a:solidFill>
-                  <a:srgbClr val="000000"/>
-                </a:solidFill>
-                <a:latin typeface="Courier New" panose="02070309020205020404" pitchFamily="49" charset="0"/>
-              </a:rPr>
-              <a:t>curr</a:t>
-            </a:r>
-            <a:r>
-              <a:rPr lang="en-US" sz="2200" dirty="0">
-                <a:solidFill>
-                  <a:srgbClr val="000000"/>
-                </a:solidFill>
-                <a:latin typeface="Courier New" panose="02070309020205020404" pitchFamily="49" charset="0"/>
-              </a:rPr>
-              <a:t> = </a:t>
-            </a:r>
-            <a:r>
-              <a:rPr lang="en-US" sz="2200" dirty="0" err="1">
-                <a:solidFill>
-                  <a:srgbClr val="000000"/>
-                </a:solidFill>
-                <a:latin typeface="Courier New" panose="02070309020205020404" pitchFamily="49" charset="0"/>
-              </a:rPr>
-              <a:t>expression.substring</a:t>
-            </a:r>
-            <a:r>
-              <a:rPr lang="en-US" sz="2200" dirty="0">
-                <a:solidFill>
-                  <a:srgbClr val="000000"/>
-                </a:solidFill>
-                <a:latin typeface="Courier New" panose="02070309020205020404" pitchFamily="49" charset="0"/>
-              </a:rPr>
-              <a:t>(i,i+1);</a:t>
-            </a:r>
-          </a:p>
-          <a:p>
-            <a:r>
-              <a:rPr lang="en-US" sz="2200" dirty="0">
-                <a:solidFill>
-                  <a:srgbClr val="000000"/>
-                </a:solidFill>
-                <a:latin typeface="Courier New" panose="02070309020205020404" pitchFamily="49" charset="0"/>
-              </a:rPr>
-              <a:t>      </a:t>
-            </a:r>
-            <a:endParaRPr lang="en-US" sz="2200" dirty="0"/>
+              <a:rPr lang="en-US" sz="2400" dirty="0">
+                <a:solidFill>
+                  <a:schemeClr val="accent6">
+                    <a:lumMod val="75000"/>
+                  </a:schemeClr>
+                </a:solidFill>
+                <a:latin typeface="Courier New" panose="02070309020205020404" pitchFamily="49" charset="0"/>
+              </a:rPr>
+              <a:t>   String[] closed = {"}", ")", "&gt;", "]"};</a:t>
+            </a:r>
+            <a:endParaRPr lang="en-US" sz="2400" dirty="0">
+              <a:solidFill>
+                <a:schemeClr val="accent6">
+                  <a:lumMod val="75000"/>
+                </a:schemeClr>
+              </a:solidFill>
+            </a:endParaRPr>
           </a:p>
         </p:txBody>
       </p:sp>
@@ -10652,6 +10356,268 @@
                 <a:latin typeface="Abadi" panose="020B0604020104020204" pitchFamily="34" charset="0"/>
               </a:rPr>
               <a:t>Arrays</a:t>
+            </a:r>
+          </a:p>
+        </p:txBody>
+      </p:sp>
+      <p:sp>
+        <p:nvSpPr>
+          <p:cNvPr id="3" name="TextBox 2">
+            <a:extLst>
+              <a:ext uri="{FF2B5EF4-FFF2-40B4-BE49-F238E27FC236}">
+                <a16:creationId xmlns:a16="http://schemas.microsoft.com/office/drawing/2014/main" id="{2C1B3639-3E52-5477-F3C6-800506B1F1D8}"/>
+              </a:ext>
+            </a:extLst>
+          </p:cNvPr>
+          <p:cNvSpPr txBox="1"/>
+          <p:nvPr/>
+        </p:nvSpPr>
+        <p:spPr>
+          <a:xfrm>
+            <a:off x="0" y="3352800"/>
+            <a:ext cx="9144000" cy="2677656"/>
+          </a:xfrm>
+          <a:prstGeom prst="rect">
+            <a:avLst/>
+          </a:prstGeom>
+          <a:noFill/>
+        </p:spPr>
+        <p:txBody>
+          <a:bodyPr wrap="square">
+            <a:spAutoFit/>
+          </a:bodyPr>
+          <a:lstStyle/>
+          <a:p>
+            <a:r>
+              <a:rPr lang="en-US" sz="2400" dirty="0">
+                <a:solidFill>
+                  <a:srgbClr val="000000"/>
+                </a:solidFill>
+                <a:latin typeface="Abadi" panose="020B0604020104020204" pitchFamily="34" charset="0"/>
+              </a:rPr>
+              <a:t>Check to see if current character is an open symbol: </a:t>
+            </a:r>
+          </a:p>
+          <a:p>
+            <a:pPr algn="ctr">
+              <a:lnSpc>
+                <a:spcPct val="150000"/>
+              </a:lnSpc>
+            </a:pPr>
+            <a:r>
+              <a:rPr lang="en-US" sz="2400" dirty="0">
+                <a:solidFill>
+                  <a:schemeClr val="accent6">
+                    <a:lumMod val="75000"/>
+                  </a:schemeClr>
+                </a:solidFill>
+                <a:latin typeface="Courier New" panose="02070309020205020404" pitchFamily="49" charset="0"/>
+              </a:rPr>
+              <a:t>if (</a:t>
+            </a:r>
+            <a:r>
+              <a:rPr lang="en-US" sz="2400" dirty="0" err="1">
+                <a:solidFill>
+                  <a:schemeClr val="accent6">
+                    <a:lumMod val="75000"/>
+                  </a:schemeClr>
+                </a:solidFill>
+                <a:latin typeface="Courier New" panose="02070309020205020404" pitchFamily="49" charset="0"/>
+              </a:rPr>
+              <a:t>open.contains</a:t>
+            </a:r>
+            <a:r>
+              <a:rPr lang="en-US" sz="2400" dirty="0">
+                <a:solidFill>
+                  <a:schemeClr val="accent6">
+                    <a:lumMod val="75000"/>
+                  </a:schemeClr>
+                </a:solidFill>
+                <a:latin typeface="Courier New" panose="02070309020205020404" pitchFamily="49" charset="0"/>
+              </a:rPr>
+              <a:t>(</a:t>
+            </a:r>
+            <a:r>
+              <a:rPr lang="en-US" sz="2400" dirty="0" err="1">
+                <a:solidFill>
+                  <a:schemeClr val="accent6">
+                    <a:lumMod val="75000"/>
+                  </a:schemeClr>
+                </a:solidFill>
+                <a:latin typeface="Courier New" panose="02070309020205020404" pitchFamily="49" charset="0"/>
+              </a:rPr>
+              <a:t>curr</a:t>
+            </a:r>
+            <a:r>
+              <a:rPr lang="en-US" sz="2400" dirty="0">
+                <a:solidFill>
+                  <a:schemeClr val="accent6">
+                    <a:lumMod val="75000"/>
+                  </a:schemeClr>
+                </a:solidFill>
+                <a:latin typeface="Courier New" panose="02070309020205020404" pitchFamily="49" charset="0"/>
+              </a:rPr>
+              <a:t>))</a:t>
+            </a:r>
+            <a:br>
+              <a:rPr lang="en-US" sz="2400" dirty="0">
+                <a:solidFill>
+                  <a:schemeClr val="accent6">
+                    <a:lumMod val="75000"/>
+                  </a:schemeClr>
+                </a:solidFill>
+                <a:latin typeface="Courier New" panose="02070309020205020404" pitchFamily="49" charset="0"/>
+              </a:rPr>
+            </a:br>
+            <a:r>
+              <a:rPr lang="en-US" sz="1800" dirty="0">
+                <a:solidFill>
+                  <a:schemeClr val="accent6">
+                    <a:lumMod val="75000"/>
+                  </a:schemeClr>
+                </a:solidFill>
+                <a:latin typeface="Courier New" panose="02070309020205020404" pitchFamily="49" charset="0"/>
+              </a:rPr>
+              <a:t>      </a:t>
+            </a:r>
+          </a:p>
+          <a:p>
+            <a:r>
+              <a:rPr lang="en-US" sz="2400" dirty="0">
+                <a:solidFill>
+                  <a:srgbClr val="000000"/>
+                </a:solidFill>
+                <a:latin typeface="Abadi" panose="020B0604020104020204" pitchFamily="34" charset="0"/>
+              </a:rPr>
+              <a:t>If current character is a closed symbol, check to see if it corresponds to the open symbol from the top of the stack:</a:t>
+            </a:r>
+          </a:p>
+          <a:p>
+            <a:pPr algn="ctr">
+              <a:lnSpc>
+                <a:spcPct val="150000"/>
+              </a:lnSpc>
+            </a:pPr>
+            <a:r>
+              <a:rPr lang="en-US" sz="2400" dirty="0" err="1">
+                <a:solidFill>
+                  <a:schemeClr val="accent6">
+                    <a:lumMod val="75000"/>
+                  </a:schemeClr>
+                </a:solidFill>
+                <a:latin typeface="Courier New" panose="02070309020205020404" pitchFamily="49" charset="0"/>
+              </a:rPr>
+              <a:t>closed.indexOf</a:t>
+            </a:r>
+            <a:r>
+              <a:rPr lang="en-US" sz="2400" dirty="0">
+                <a:solidFill>
+                  <a:schemeClr val="accent6">
+                    <a:lumMod val="75000"/>
+                  </a:schemeClr>
+                </a:solidFill>
+                <a:latin typeface="Courier New" panose="02070309020205020404" pitchFamily="49" charset="0"/>
+              </a:rPr>
+              <a:t>(</a:t>
+            </a:r>
+            <a:r>
+              <a:rPr lang="en-US" sz="2400" dirty="0" err="1">
+                <a:solidFill>
+                  <a:schemeClr val="accent6">
+                    <a:lumMod val="75000"/>
+                  </a:schemeClr>
+                </a:solidFill>
+                <a:latin typeface="Courier New" panose="02070309020205020404" pitchFamily="49" charset="0"/>
+              </a:rPr>
+              <a:t>curr</a:t>
+            </a:r>
+            <a:r>
+              <a:rPr lang="en-US" sz="2400" dirty="0">
+                <a:solidFill>
+                  <a:schemeClr val="accent6">
+                    <a:lumMod val="75000"/>
+                  </a:schemeClr>
+                </a:solidFill>
+                <a:latin typeface="Courier New" panose="02070309020205020404" pitchFamily="49" charset="0"/>
+              </a:rPr>
+              <a:t>)</a:t>
+            </a:r>
+            <a:r>
+              <a:rPr lang="en-US" sz="1200" dirty="0">
+                <a:solidFill>
+                  <a:schemeClr val="accent6">
+                    <a:lumMod val="75000"/>
+                  </a:schemeClr>
+                </a:solidFill>
+                <a:latin typeface="Courier New" panose="02070309020205020404" pitchFamily="49" charset="0"/>
+              </a:rPr>
+              <a:t> </a:t>
+            </a:r>
+            <a:r>
+              <a:rPr lang="en-US" sz="2400" dirty="0">
+                <a:solidFill>
+                  <a:schemeClr val="accent6">
+                    <a:lumMod val="75000"/>
+                  </a:schemeClr>
+                </a:solidFill>
+                <a:latin typeface="Courier New" panose="02070309020205020404" pitchFamily="49" charset="0"/>
+              </a:rPr>
+              <a:t>==</a:t>
+            </a:r>
+            <a:r>
+              <a:rPr lang="en-US" sz="1200" dirty="0">
+                <a:solidFill>
+                  <a:schemeClr val="accent6">
+                    <a:lumMod val="75000"/>
+                  </a:schemeClr>
+                </a:solidFill>
+                <a:latin typeface="Courier New" panose="02070309020205020404" pitchFamily="49" charset="0"/>
+              </a:rPr>
+              <a:t> </a:t>
+            </a:r>
+            <a:r>
+              <a:rPr lang="en-US" sz="2400" dirty="0" err="1">
+                <a:solidFill>
+                  <a:schemeClr val="accent6">
+                    <a:lumMod val="75000"/>
+                  </a:schemeClr>
+                </a:solidFill>
+                <a:latin typeface="Courier New" panose="02070309020205020404" pitchFamily="49" charset="0"/>
+              </a:rPr>
+              <a:t>open.indexOf</a:t>
+            </a:r>
+            <a:r>
+              <a:rPr lang="en-US" sz="2400" dirty="0">
+                <a:solidFill>
+                  <a:schemeClr val="accent6">
+                    <a:lumMod val="75000"/>
+                  </a:schemeClr>
+                </a:solidFill>
+                <a:latin typeface="Courier New" panose="02070309020205020404" pitchFamily="49" charset="0"/>
+              </a:rPr>
+              <a:t>(</a:t>
+            </a:r>
+            <a:r>
+              <a:rPr lang="en-US" sz="2400" dirty="0" err="1">
+                <a:solidFill>
+                  <a:schemeClr val="accent6">
+                    <a:lumMod val="75000"/>
+                  </a:schemeClr>
+                </a:solidFill>
+                <a:latin typeface="Courier New" panose="02070309020205020404" pitchFamily="49" charset="0"/>
+              </a:rPr>
+              <a:t>stack.pop</a:t>
+            </a:r>
+            <a:r>
+              <a:rPr lang="en-US" sz="2400" dirty="0">
+                <a:solidFill>
+                  <a:schemeClr val="accent6">
+                    <a:lumMod val="75000"/>
+                  </a:schemeClr>
+                </a:solidFill>
+                <a:latin typeface="Courier New" panose="02070309020205020404" pitchFamily="49" charset="0"/>
+              </a:rPr>
+              <a:t>())</a:t>
             </a:r>
           </a:p>
         </p:txBody>
@@ -10700,8 +10666,8 @@
         </p:nvSpPr>
         <p:spPr>
           <a:xfrm>
-            <a:off x="266700" y="1373862"/>
-            <a:ext cx="8610600" cy="4493538"/>
+            <a:off x="266700" y="1066800"/>
+            <a:ext cx="8610600" cy="2462213"/>
           </a:xfrm>
           <a:prstGeom prst="rect">
             <a:avLst/>
@@ -10716,103 +10682,53 @@
           <a:p>
             <a:r>
               <a:rPr lang="en-US" sz="2200" dirty="0">
-                <a:solidFill>
-                  <a:srgbClr val="941EDF"/>
-                </a:solidFill>
-                <a:latin typeface="Courier New" panose="02070309020205020404" pitchFamily="49" charset="0"/>
-              </a:rPr>
-              <a:t>public</a:t>
+                <a:latin typeface="Courier New" panose="02070309020205020404" pitchFamily="49" charset="0"/>
+              </a:rPr>
+              <a:t>public </a:t>
+            </a:r>
+            <a:r>
+              <a:rPr lang="en-US" sz="2200" dirty="0" err="1">
+                <a:latin typeface="Courier New" panose="02070309020205020404" pitchFamily="49" charset="0"/>
+              </a:rPr>
+              <a:t>boolean</a:t>
             </a:r>
             <a:r>
               <a:rPr lang="en-US" sz="2200" dirty="0">
-                <a:solidFill>
-                  <a:srgbClr val="000000"/>
-                </a:solidFill>
                 <a:latin typeface="Courier New" panose="02070309020205020404" pitchFamily="49" charset="0"/>
               </a:rPr>
               <a:t> </a:t>
             </a:r>
             <a:r>
               <a:rPr lang="en-US" sz="2200" dirty="0" err="1">
-                <a:solidFill>
-                  <a:srgbClr val="941EDF"/>
-                </a:solidFill>
-                <a:latin typeface="Courier New" panose="02070309020205020404" pitchFamily="49" charset="0"/>
-              </a:rPr>
-              <a:t>boolean</a:t>
+                <a:latin typeface="Courier New" panose="02070309020205020404" pitchFamily="49" charset="0"/>
+              </a:rPr>
+              <a:t>checkExpression</a:t>
             </a:r>
             <a:r>
               <a:rPr lang="en-US" sz="2200" dirty="0">
-                <a:solidFill>
-                  <a:srgbClr val="000000"/>
-                </a:solidFill>
-                <a:latin typeface="Courier New" panose="02070309020205020404" pitchFamily="49" charset="0"/>
-              </a:rPr>
-              <a:t> </a:t>
-            </a:r>
-            <a:r>
-              <a:rPr lang="en-US" sz="2200" dirty="0" err="1">
-                <a:solidFill>
-                  <a:srgbClr val="000000"/>
-                </a:solidFill>
-                <a:latin typeface="Courier New" panose="02070309020205020404" pitchFamily="49" charset="0"/>
-              </a:rPr>
-              <a:t>checkExpression</a:t>
-            </a:r>
-            <a:r>
-              <a:rPr lang="en-US" sz="2200" dirty="0">
-                <a:solidFill>
-                  <a:srgbClr val="000000"/>
-                </a:solidFill>
                 <a:latin typeface="Courier New" panose="02070309020205020404" pitchFamily="49" charset="0"/>
               </a:rPr>
               <a:t>() {</a:t>
             </a:r>
             <a:br>
               <a:rPr lang="en-US" sz="2200" dirty="0">
+                <a:latin typeface="Courier New" panose="02070309020205020404" pitchFamily="49" charset="0"/>
+              </a:rPr>
+            </a:br>
+            <a:r>
+              <a:rPr lang="en-US" sz="2200" dirty="0">
+                <a:latin typeface="Courier New" panose="02070309020205020404" pitchFamily="49" charset="0"/>
+              </a:rPr>
+              <a:t>   Stack&lt;String&gt; stack = new Stack</a:t>
+            </a:r>
+            <a:r>
+              <a:rPr lang="en-US" sz="2200" dirty="0">
                 <a:solidFill>
                   <a:srgbClr val="000000"/>
                 </a:solidFill>
                 <a:latin typeface="Courier New" panose="02070309020205020404" pitchFamily="49" charset="0"/>
               </a:rPr>
-            </a:br>
-            <a:r>
-              <a:rPr lang="en-US" sz="2200" dirty="0">
-                <a:solidFill>
-                  <a:srgbClr val="000000"/>
-                </a:solidFill>
-                <a:latin typeface="Courier New" panose="02070309020205020404" pitchFamily="49" charset="0"/>
-              </a:rPr>
-              <a:t>   Stack&lt;String&gt; symbols;</a:t>
-            </a:r>
-          </a:p>
-          <a:p>
-            <a:r>
-              <a:rPr lang="en-US" sz="2200" dirty="0">
-                <a:solidFill>
-                  <a:srgbClr val="000000"/>
-                </a:solidFill>
-                <a:latin typeface="Courier New" panose="02070309020205020404" pitchFamily="49" charset="0"/>
-              </a:rPr>
-              <a:t>   symbols = </a:t>
-            </a:r>
-            <a:r>
-              <a:rPr lang="en-US" sz="2200" dirty="0">
-                <a:solidFill>
-                  <a:srgbClr val="941EDF"/>
-                </a:solidFill>
-                <a:latin typeface="Courier New" panose="02070309020205020404" pitchFamily="49" charset="0"/>
-              </a:rPr>
-              <a:t>new</a:t>
-            </a:r>
-            <a:r>
-              <a:rPr lang="en-US" sz="2200" dirty="0">
-                <a:solidFill>
-                  <a:srgbClr val="000000"/>
-                </a:solidFill>
-                <a:latin typeface="Courier New" panose="02070309020205020404" pitchFamily="49" charset="0"/>
-              </a:rPr>
-              <a:t> Stack&lt;String&gt;();</a:t>
+              <a:t>&lt;&gt;();</a:t>
             </a:r>
             <a:br>
               <a:rPr lang="en-US" sz="2200" dirty="0">
@@ -10825,7 +10741,9 @@
             <a:r>
               <a:rPr lang="en-US" sz="2200" dirty="0">
                 <a:solidFill>
-                  <a:srgbClr val="000000"/>
+                  <a:schemeClr val="accent6">
+                    <a:lumMod val="75000"/>
+                  </a:schemeClr>
                 </a:solidFill>
                 <a:latin typeface="Courier New" panose="02070309020205020404" pitchFamily="49" charset="0"/>
               </a:rPr>
@@ -10834,7 +10752,9 @@
             <a:r>
               <a:rPr lang="en-US" sz="2200" dirty="0" err="1">
                 <a:solidFill>
-                  <a:srgbClr val="000000"/>
+                  <a:schemeClr val="accent6">
+                    <a:lumMod val="75000"/>
+                  </a:schemeClr>
                 </a:solidFill>
                 <a:latin typeface="Courier New" panose="02070309020205020404" pitchFamily="49" charset="0"/>
               </a:rPr>
@@ -10843,43 +10763,31 @@
             <a:r>
               <a:rPr lang="en-US" sz="2200" dirty="0">
                 <a:solidFill>
-                  <a:srgbClr val="000000"/>
-                </a:solidFill>
-                <a:latin typeface="Courier New" panose="02070309020205020404" pitchFamily="49" charset="0"/>
-              </a:rPr>
-              <a:t>&lt;String&gt; open = </a:t>
+                  <a:schemeClr val="accent6">
+                    <a:lumMod val="75000"/>
+                  </a:schemeClr>
+                </a:solidFill>
+                <a:latin typeface="Courier New" panose="02070309020205020404" pitchFamily="49" charset="0"/>
+              </a:rPr>
+              <a:t>&lt;String&gt; open = new </a:t>
+            </a:r>
+            <a:r>
+              <a:rPr lang="en-US" sz="2200" dirty="0" err="1">
+                <a:solidFill>
+                  <a:schemeClr val="accent6">
+                    <a:lumMod val="75000"/>
+                  </a:schemeClr>
+                </a:solidFill>
+                <a:latin typeface="Courier New" panose="02070309020205020404" pitchFamily="49" charset="0"/>
+              </a:rPr>
+              <a:t>ArrayList</a:t>
             </a:r>
             <a:r>
               <a:rPr lang="en-US" sz="2200" dirty="0">
                 <a:solidFill>
-                  <a:srgbClr val="941EDF"/>
-                </a:solidFill>
-                <a:latin typeface="Courier New" panose="02070309020205020404" pitchFamily="49" charset="0"/>
-              </a:rPr>
-              <a:t>new</a:t>
-            </a:r>
-            <a:r>
-              <a:rPr lang="en-US" sz="2200" dirty="0">
-                <a:solidFill>
-                  <a:srgbClr val="000000"/>
-                </a:solidFill>
-                <a:latin typeface="Courier New" panose="02070309020205020404" pitchFamily="49" charset="0"/>
-              </a:rPr>
-              <a:t> </a:t>
-            </a:r>
-            <a:r>
-              <a:rPr lang="en-US" sz="2200" dirty="0" err="1">
-                <a:solidFill>
-                  <a:srgbClr val="000000"/>
-                </a:solidFill>
-                <a:latin typeface="Courier New" panose="02070309020205020404" pitchFamily="49" charset="0"/>
-              </a:rPr>
-              <a:t>ArrayList</a:t>
-            </a:r>
-            <a:r>
-              <a:rPr lang="en-US" sz="2200" dirty="0">
-                <a:solidFill>
-                  <a:srgbClr val="000000"/>
+                  <a:schemeClr val="accent6">
+                    <a:lumMod val="75000"/>
+                  </a:schemeClr>
                 </a:solidFill>
                 <a:latin typeface="Courier New" panose="02070309020205020404" pitchFamily="49" charset="0"/>
               </a:rPr>
@@ -10888,7 +10796,9 @@
             <a:br>
               <a:rPr lang="en-US" sz="2200" dirty="0">
                 <a:solidFill>
-                  <a:srgbClr val="000000"/>
+                  <a:schemeClr val="accent6">
+                    <a:lumMod val="75000"/>
+                  </a:schemeClr>
                 </a:solidFill>
                 <a:latin typeface="Courier New" panose="02070309020205020404" pitchFamily="49" charset="0"/>
               </a:rPr>
@@ -10896,7 +10806,9 @@
             <a:r>
               <a:rPr lang="en-US" sz="2200" dirty="0">
                 <a:solidFill>
-                  <a:srgbClr val="000000"/>
+                  <a:schemeClr val="accent6">
+                    <a:lumMod val="75000"/>
+                  </a:schemeClr>
                 </a:solidFill>
                 <a:latin typeface="Courier New" panose="02070309020205020404" pitchFamily="49" charset="0"/>
               </a:rPr>
@@ -10905,7 +10817,9 @@
             <a:r>
               <a:rPr lang="en-US" sz="2200" dirty="0" err="1">
                 <a:solidFill>
-                  <a:srgbClr val="000000"/>
+                  <a:schemeClr val="accent6">
+                    <a:lumMod val="75000"/>
+                  </a:schemeClr>
                 </a:solidFill>
                 <a:latin typeface="Courier New" panose="02070309020205020404" pitchFamily="49" charset="0"/>
               </a:rPr>
@@ -10914,88 +10828,20 @@
             <a:r>
               <a:rPr lang="en-US" sz="2200" dirty="0">
                 <a:solidFill>
-                  <a:srgbClr val="000000"/>
-                </a:solidFill>
-                <a:latin typeface="Courier New" panose="02070309020205020404" pitchFamily="49" charset="0"/>
-              </a:rPr>
-              <a:t>(open, </a:t>
-            </a:r>
-            <a:r>
-              <a:rPr lang="en-US" sz="2200" dirty="0">
-                <a:solidFill>
-                  <a:srgbClr val="00A000"/>
-                </a:solidFill>
-                <a:latin typeface="Courier New" panose="02070309020205020404" pitchFamily="49" charset="0"/>
-              </a:rPr>
-              <a:t>"{"</a:t>
-            </a:r>
-            <a:r>
-              <a:rPr lang="en-US" sz="2200" dirty="0">
-                <a:solidFill>
-                  <a:srgbClr val="000000"/>
-                </a:solidFill>
-                <a:latin typeface="Courier New" panose="02070309020205020404" pitchFamily="49" charset="0"/>
-              </a:rPr>
-              <a:t>, </a:t>
-            </a:r>
-            <a:r>
-              <a:rPr lang="en-US" sz="2200" dirty="0">
-                <a:solidFill>
-                  <a:srgbClr val="00A000"/>
-                </a:solidFill>
-                <a:latin typeface="Courier New" panose="02070309020205020404" pitchFamily="49" charset="0"/>
-              </a:rPr>
-              <a:t>"("</a:t>
-            </a:r>
-            <a:r>
-              <a:rPr lang="en-US" sz="2200" dirty="0">
-                <a:solidFill>
-                  <a:srgbClr val="000000"/>
-                </a:solidFill>
-                <a:latin typeface="Courier New" panose="02070309020205020404" pitchFamily="49" charset="0"/>
-              </a:rPr>
-              <a:t>, </a:t>
-            </a:r>
-            <a:r>
-              <a:rPr lang="en-US" sz="2200" dirty="0">
-                <a:solidFill>
-                  <a:srgbClr val="00A000"/>
-                </a:solidFill>
-                <a:latin typeface="Courier New" panose="02070309020205020404" pitchFamily="49" charset="0"/>
-              </a:rPr>
-              <a:t>"&lt;"</a:t>
-            </a:r>
-            <a:r>
-              <a:rPr lang="en-US" sz="2200" dirty="0">
-                <a:solidFill>
-                  <a:srgbClr val="000000"/>
-                </a:solidFill>
-                <a:latin typeface="Courier New" panose="02070309020205020404" pitchFamily="49" charset="0"/>
-              </a:rPr>
-              <a:t>, </a:t>
-            </a:r>
-            <a:r>
-              <a:rPr lang="en-US" sz="2200" dirty="0">
-                <a:solidFill>
-                  <a:srgbClr val="00A000"/>
-                </a:solidFill>
-                <a:latin typeface="Courier New" panose="02070309020205020404" pitchFamily="49" charset="0"/>
-              </a:rPr>
-              <a:t>"["</a:t>
-            </a:r>
-            <a:r>
-              <a:rPr lang="en-US" sz="2200" dirty="0">
-                <a:solidFill>
-                  <a:srgbClr val="000000"/>
-                </a:solidFill>
-                <a:latin typeface="Courier New" panose="02070309020205020404" pitchFamily="49" charset="0"/>
-              </a:rPr>
-              <a:t>);</a:t>
+                  <a:schemeClr val="accent6">
+                    <a:lumMod val="75000"/>
+                  </a:schemeClr>
+                </a:solidFill>
+                <a:latin typeface="Courier New" panose="02070309020205020404" pitchFamily="49" charset="0"/>
+              </a:rPr>
+              <a:t>(open, "{", "(", "&lt;", "[");</a:t>
             </a:r>
             <a:br>
               <a:rPr lang="en-US" sz="2200" dirty="0">
                 <a:solidFill>
-                  <a:srgbClr val="000000"/>
+                  <a:schemeClr val="accent6">
+                    <a:lumMod val="75000"/>
+                  </a:schemeClr>
                 </a:solidFill>
                 <a:latin typeface="Courier New" panose="02070309020205020404" pitchFamily="49" charset="0"/>
               </a:rPr>
@@ -11003,7 +10849,9 @@
             <a:r>
               <a:rPr lang="en-US" sz="2200" dirty="0">
                 <a:solidFill>
-                  <a:srgbClr val="000000"/>
+                  <a:schemeClr val="accent6">
+                    <a:lumMod val="75000"/>
+                  </a:schemeClr>
                 </a:solidFill>
                 <a:latin typeface="Courier New" panose="02070309020205020404" pitchFamily="49" charset="0"/>
               </a:rPr>
@@ -11012,7 +10860,9 @@
             <a:br>
               <a:rPr lang="en-US" sz="2200" dirty="0">
                 <a:solidFill>
-                  <a:srgbClr val="000000"/>
+                  <a:schemeClr val="accent6">
+                    <a:lumMod val="75000"/>
+                  </a:schemeClr>
                 </a:solidFill>
                 <a:latin typeface="Courier New" panose="02070309020205020404" pitchFamily="49" charset="0"/>
               </a:rPr>
@@ -11020,7 +10870,9 @@
             <a:r>
               <a:rPr lang="en-US" sz="2200" dirty="0">
                 <a:solidFill>
-                  <a:srgbClr val="000000"/>
+                  <a:schemeClr val="accent6">
+                    <a:lumMod val="75000"/>
+                  </a:schemeClr>
                 </a:solidFill>
                 <a:latin typeface="Courier New" panose="02070309020205020404" pitchFamily="49" charset="0"/>
               </a:rPr>
@@ -11029,7 +10881,9 @@
             <a:r>
               <a:rPr lang="en-US" sz="2200" dirty="0" err="1">
                 <a:solidFill>
-                  <a:srgbClr val="000000"/>
+                  <a:schemeClr val="accent6">
+                    <a:lumMod val="75000"/>
+                  </a:schemeClr>
                 </a:solidFill>
                 <a:latin typeface="Courier New" panose="02070309020205020404" pitchFamily="49" charset="0"/>
               </a:rPr>
@@ -11038,43 +10892,31 @@
             <a:r>
               <a:rPr lang="en-US" sz="2200" dirty="0">
                 <a:solidFill>
-                  <a:srgbClr val="000000"/>
-                </a:solidFill>
-                <a:latin typeface="Courier New" panose="02070309020205020404" pitchFamily="49" charset="0"/>
-              </a:rPr>
-              <a:t>&lt;String&gt; close = </a:t>
+                  <a:schemeClr val="accent6">
+                    <a:lumMod val="75000"/>
+                  </a:schemeClr>
+                </a:solidFill>
+                <a:latin typeface="Courier New" panose="02070309020205020404" pitchFamily="49" charset="0"/>
+              </a:rPr>
+              <a:t>&lt;String&gt; close = new </a:t>
+            </a:r>
+            <a:r>
+              <a:rPr lang="en-US" sz="2200" dirty="0" err="1">
+                <a:solidFill>
+                  <a:schemeClr val="accent6">
+                    <a:lumMod val="75000"/>
+                  </a:schemeClr>
+                </a:solidFill>
+                <a:latin typeface="Courier New" panose="02070309020205020404" pitchFamily="49" charset="0"/>
+              </a:rPr>
+              <a:t>ArrayList</a:t>
             </a:r>
             <a:r>
               <a:rPr lang="en-US" sz="2200" dirty="0">
                 <a:solidFill>
-                  <a:srgbClr val="941EDF"/>
-                </a:solidFill>
-                <a:latin typeface="Courier New" panose="02070309020205020404" pitchFamily="49" charset="0"/>
-              </a:rPr>
-              <a:t>new</a:t>
-            </a:r>
-            <a:r>
-              <a:rPr lang="en-US" sz="2200" dirty="0">
-                <a:solidFill>
-                  <a:srgbClr val="000000"/>
-                </a:solidFill>
-                <a:latin typeface="Courier New" panose="02070309020205020404" pitchFamily="49" charset="0"/>
-              </a:rPr>
-              <a:t> </a:t>
-            </a:r>
-            <a:r>
-              <a:rPr lang="en-US" sz="2200" dirty="0" err="1">
-                <a:solidFill>
-                  <a:srgbClr val="000000"/>
-                </a:solidFill>
-                <a:latin typeface="Courier New" panose="02070309020205020404" pitchFamily="49" charset="0"/>
-              </a:rPr>
-              <a:t>ArrayList</a:t>
-            </a:r>
-            <a:r>
-              <a:rPr lang="en-US" sz="2200" dirty="0">
-                <a:solidFill>
-                  <a:srgbClr val="000000"/>
+                  <a:schemeClr val="accent6">
+                    <a:lumMod val="75000"/>
+                  </a:schemeClr>
                 </a:solidFill>
                 <a:latin typeface="Courier New" panose="02070309020205020404" pitchFamily="49" charset="0"/>
               </a:rPr>
@@ -11083,7 +10925,9 @@
             <a:br>
               <a:rPr lang="en-US" sz="2200" dirty="0">
                 <a:solidFill>
-                  <a:srgbClr val="000000"/>
+                  <a:schemeClr val="accent6">
+                    <a:lumMod val="75000"/>
+                  </a:schemeClr>
                 </a:solidFill>
                 <a:latin typeface="Courier New" panose="02070309020205020404" pitchFamily="49" charset="0"/>
               </a:rPr>
@@ -11091,7 +10935,9 @@
             <a:r>
               <a:rPr lang="en-US" sz="2200" dirty="0">
                 <a:solidFill>
-                  <a:srgbClr val="000000"/>
+                  <a:schemeClr val="accent6">
+                    <a:lumMod val="75000"/>
+                  </a:schemeClr>
                 </a:solidFill>
                 <a:latin typeface="Courier New" panose="02070309020205020404" pitchFamily="49" charset="0"/>
               </a:rPr>
@@ -11100,7 +10946,9 @@
             <a:r>
               <a:rPr lang="en-US" sz="2200" dirty="0" err="1">
                 <a:solidFill>
-                  <a:srgbClr val="000000"/>
+                  <a:schemeClr val="accent6">
+                    <a:lumMod val="75000"/>
+                  </a:schemeClr>
                 </a:solidFill>
                 <a:latin typeface="Courier New" panose="02070309020205020404" pitchFamily="49" charset="0"/>
               </a:rPr>
@@ -11109,245 +10957,21 @@
             <a:r>
               <a:rPr lang="en-US" sz="2200" dirty="0">
                 <a:solidFill>
-                  <a:srgbClr val="000000"/>
-                </a:solidFill>
-                <a:latin typeface="Courier New" panose="02070309020205020404" pitchFamily="49" charset="0"/>
-              </a:rPr>
-              <a:t>(close, </a:t>
-            </a:r>
-            <a:r>
-              <a:rPr lang="en-US" sz="2200" dirty="0">
-                <a:solidFill>
-                  <a:srgbClr val="00A000"/>
-                </a:solidFill>
-                <a:latin typeface="Courier New" panose="02070309020205020404" pitchFamily="49" charset="0"/>
-              </a:rPr>
-              <a:t>"}"</a:t>
-            </a:r>
-            <a:r>
-              <a:rPr lang="en-US" sz="2200" dirty="0">
-                <a:solidFill>
-                  <a:srgbClr val="000000"/>
-                </a:solidFill>
-                <a:latin typeface="Courier New" panose="02070309020205020404" pitchFamily="49" charset="0"/>
-              </a:rPr>
-              <a:t>, </a:t>
-            </a:r>
-            <a:r>
-              <a:rPr lang="en-US" sz="2200" dirty="0">
-                <a:solidFill>
-                  <a:srgbClr val="00A000"/>
-                </a:solidFill>
-                <a:latin typeface="Courier New" panose="02070309020205020404" pitchFamily="49" charset="0"/>
-              </a:rPr>
-              <a:t>")"</a:t>
-            </a:r>
-            <a:r>
-              <a:rPr lang="en-US" sz="2200" dirty="0">
-                <a:solidFill>
-                  <a:srgbClr val="000000"/>
-                </a:solidFill>
-                <a:latin typeface="Courier New" panose="02070309020205020404" pitchFamily="49" charset="0"/>
-              </a:rPr>
-              <a:t>, </a:t>
-            </a:r>
-            <a:r>
-              <a:rPr lang="en-US" sz="2200" dirty="0">
-                <a:solidFill>
-                  <a:srgbClr val="00A000"/>
-                </a:solidFill>
-                <a:latin typeface="Courier New" panose="02070309020205020404" pitchFamily="49" charset="0"/>
-              </a:rPr>
-              <a:t>"&gt;"</a:t>
-            </a:r>
-            <a:r>
-              <a:rPr lang="en-US" sz="2200" dirty="0">
-                <a:solidFill>
-                  <a:srgbClr val="000000"/>
-                </a:solidFill>
-                <a:latin typeface="Courier New" panose="02070309020205020404" pitchFamily="49" charset="0"/>
-              </a:rPr>
-              <a:t>, </a:t>
-            </a:r>
-            <a:r>
-              <a:rPr lang="en-US" sz="2200" dirty="0">
-                <a:solidFill>
-                  <a:srgbClr val="00A000"/>
-                </a:solidFill>
-                <a:latin typeface="Courier New" panose="02070309020205020404" pitchFamily="49" charset="0"/>
-              </a:rPr>
-              <a:t>"]"</a:t>
-            </a:r>
-            <a:r>
-              <a:rPr lang="en-US" sz="2200" dirty="0">
-                <a:solidFill>
-                  <a:srgbClr val="000000"/>
-                </a:solidFill>
-                <a:latin typeface="Courier New" panose="02070309020205020404" pitchFamily="49" charset="0"/>
-              </a:rPr>
-              <a:t>);</a:t>
-            </a:r>
-            <a:br>
-              <a:rPr lang="en-US" sz="2200" dirty="0">
-                <a:solidFill>
-                  <a:srgbClr val="000000"/>
-                </a:solidFill>
-                <a:latin typeface="Courier New" panose="02070309020205020404" pitchFamily="49" charset="0"/>
-              </a:rPr>
-            </a:br>
-            <a:br>
-              <a:rPr lang="en-US" sz="2200" dirty="0">
-                <a:solidFill>
-                  <a:srgbClr val="000000"/>
-                </a:solidFill>
-                <a:latin typeface="Courier New" panose="02070309020205020404" pitchFamily="49" charset="0"/>
-              </a:rPr>
-            </a:br>
-            <a:r>
-              <a:rPr lang="en-US" sz="2200" dirty="0">
-                <a:solidFill>
-                  <a:srgbClr val="000000"/>
-                </a:solidFill>
-                <a:latin typeface="Courier New" panose="02070309020205020404" pitchFamily="49" charset="0"/>
-              </a:rPr>
-              <a:t>   </a:t>
-            </a:r>
-            <a:r>
-              <a:rPr lang="en-US" sz="2200" dirty="0">
-                <a:solidFill>
-                  <a:srgbClr val="941EDF"/>
-                </a:solidFill>
-                <a:latin typeface="Courier New" panose="02070309020205020404" pitchFamily="49" charset="0"/>
-              </a:rPr>
-              <a:t>for</a:t>
-            </a:r>
-            <a:r>
-              <a:rPr lang="en-US" sz="2200" dirty="0">
-                <a:solidFill>
-                  <a:srgbClr val="000000"/>
-                </a:solidFill>
-                <a:latin typeface="Courier New" panose="02070309020205020404" pitchFamily="49" charset="0"/>
-              </a:rPr>
-              <a:t>(</a:t>
-            </a:r>
-            <a:r>
-              <a:rPr lang="en-US" sz="2200" dirty="0">
-                <a:solidFill>
-                  <a:srgbClr val="941EDF"/>
-                </a:solidFill>
-                <a:latin typeface="Courier New" panose="02070309020205020404" pitchFamily="49" charset="0"/>
-              </a:rPr>
-              <a:t>int</a:t>
-            </a:r>
-            <a:r>
-              <a:rPr lang="en-US" sz="2200" dirty="0">
-                <a:solidFill>
-                  <a:srgbClr val="000000"/>
-                </a:solidFill>
-                <a:latin typeface="Courier New" panose="02070309020205020404" pitchFamily="49" charset="0"/>
-              </a:rPr>
-              <a:t> i=0; i &lt; </a:t>
-            </a:r>
-            <a:r>
-              <a:rPr lang="en-US" sz="2200" dirty="0" err="1">
-                <a:solidFill>
-                  <a:srgbClr val="000000"/>
-                </a:solidFill>
-                <a:latin typeface="Courier New" panose="02070309020205020404" pitchFamily="49" charset="0"/>
-              </a:rPr>
-              <a:t>expression.length</a:t>
-            </a:r>
-            <a:r>
-              <a:rPr lang="en-US" sz="2200" dirty="0">
-                <a:solidFill>
-                  <a:srgbClr val="000000"/>
-                </a:solidFill>
-                <a:latin typeface="Courier New" panose="02070309020205020404" pitchFamily="49" charset="0"/>
-              </a:rPr>
-              <a:t>();  i++) </a:t>
-            </a:r>
-            <a:br>
-              <a:rPr lang="en-US" sz="2200" dirty="0">
-                <a:solidFill>
-                  <a:srgbClr val="000000"/>
-                </a:solidFill>
-                <a:latin typeface="Courier New" panose="02070309020205020404" pitchFamily="49" charset="0"/>
-              </a:rPr>
-            </a:br>
-            <a:r>
-              <a:rPr lang="en-US" sz="2200" dirty="0">
-                <a:solidFill>
-                  <a:srgbClr val="000000"/>
-                </a:solidFill>
-                <a:latin typeface="Courier New" panose="02070309020205020404" pitchFamily="49" charset="0"/>
-              </a:rPr>
-              <a:t>   {</a:t>
-            </a:r>
-            <a:br>
-              <a:rPr lang="en-US" sz="2200" dirty="0">
-                <a:solidFill>
-                  <a:srgbClr val="000000"/>
-                </a:solidFill>
-                <a:latin typeface="Courier New" panose="02070309020205020404" pitchFamily="49" charset="0"/>
-              </a:rPr>
-            </a:br>
-            <a:r>
-              <a:rPr lang="en-US" sz="2200" dirty="0">
-                <a:solidFill>
-                  <a:srgbClr val="000000"/>
-                </a:solidFill>
-                <a:latin typeface="Courier New" panose="02070309020205020404" pitchFamily="49" charset="0"/>
-              </a:rPr>
-              <a:t>      String </a:t>
-            </a:r>
-            <a:r>
-              <a:rPr lang="en-US" sz="2200" dirty="0" err="1">
-                <a:solidFill>
-                  <a:srgbClr val="000000"/>
-                </a:solidFill>
-                <a:latin typeface="Courier New" panose="02070309020205020404" pitchFamily="49" charset="0"/>
-              </a:rPr>
-              <a:t>curr</a:t>
-            </a:r>
-            <a:r>
-              <a:rPr lang="en-US" sz="2200" dirty="0">
-                <a:solidFill>
-                  <a:srgbClr val="000000"/>
-                </a:solidFill>
-                <a:latin typeface="Courier New" panose="02070309020205020404" pitchFamily="49" charset="0"/>
-              </a:rPr>
-              <a:t> = </a:t>
-            </a:r>
-            <a:r>
-              <a:rPr lang="en-US" sz="2200" dirty="0" err="1">
-                <a:solidFill>
-                  <a:srgbClr val="000000"/>
-                </a:solidFill>
-                <a:latin typeface="Courier New" panose="02070309020205020404" pitchFamily="49" charset="0"/>
-              </a:rPr>
-              <a:t>expression.substring</a:t>
-            </a:r>
-            <a:r>
-              <a:rPr lang="en-US" sz="2200" dirty="0">
-                <a:solidFill>
-                  <a:srgbClr val="000000"/>
-                </a:solidFill>
-                <a:latin typeface="Courier New" panose="02070309020205020404" pitchFamily="49" charset="0"/>
-              </a:rPr>
-              <a:t>(i,i+1);</a:t>
-            </a:r>
-          </a:p>
-          <a:p>
-            <a:r>
-              <a:rPr lang="en-US" sz="2200" dirty="0">
-                <a:solidFill>
-                  <a:srgbClr val="000000"/>
-                </a:solidFill>
-                <a:latin typeface="Courier New" panose="02070309020205020404" pitchFamily="49" charset="0"/>
-              </a:rPr>
-              <a:t>      </a:t>
-            </a:r>
-            <a:endParaRPr lang="en-US" sz="2200" dirty="0"/>
+                  <a:schemeClr val="accent6">
+                    <a:lumMod val="75000"/>
+                  </a:schemeClr>
+                </a:solidFill>
+                <a:latin typeface="Courier New" panose="02070309020205020404" pitchFamily="49" charset="0"/>
+              </a:rPr>
+              <a:t>(close, "}", ")", "&gt;", "]");     </a:t>
+            </a:r>
+            <a:endParaRPr lang="en-US" sz="2200" dirty="0">
+              <a:solidFill>
+                <a:schemeClr val="accent6">
+                  <a:lumMod val="75000"/>
+                </a:schemeClr>
+              </a:solidFill>
+            </a:endParaRPr>
           </a:p>
         </p:txBody>
       </p:sp>
@@ -11568,6 +11192,268 @@
               </a:solidFill>
               <a:latin typeface="Abadi" panose="020B0604020104020204" pitchFamily="34" charset="0"/>
             </a:endParaRPr>
+          </a:p>
+        </p:txBody>
+      </p:sp>
+      <p:sp>
+        <p:nvSpPr>
+          <p:cNvPr id="2" name="TextBox 1">
+            <a:extLst>
+              <a:ext uri="{FF2B5EF4-FFF2-40B4-BE49-F238E27FC236}">
+                <a16:creationId xmlns:a16="http://schemas.microsoft.com/office/drawing/2014/main" id="{73F45C62-B3FE-DEDE-D8D8-EC3908106EFB}"/>
+              </a:ext>
+            </a:extLst>
+          </p:cNvPr>
+          <p:cNvSpPr txBox="1"/>
+          <p:nvPr/>
+        </p:nvSpPr>
+        <p:spPr>
+          <a:xfrm>
+            <a:off x="0" y="3951744"/>
+            <a:ext cx="9144000" cy="2677656"/>
+          </a:xfrm>
+          <a:prstGeom prst="rect">
+            <a:avLst/>
+          </a:prstGeom>
+          <a:noFill/>
+        </p:spPr>
+        <p:txBody>
+          <a:bodyPr wrap="square">
+            <a:spAutoFit/>
+          </a:bodyPr>
+          <a:lstStyle/>
+          <a:p>
+            <a:r>
+              <a:rPr lang="en-US" sz="2400" dirty="0">
+                <a:solidFill>
+                  <a:srgbClr val="000000"/>
+                </a:solidFill>
+                <a:latin typeface="Abadi" panose="020B0604020104020204" pitchFamily="34" charset="0"/>
+              </a:rPr>
+              <a:t>Check to see if current character is an open symbol: </a:t>
+            </a:r>
+          </a:p>
+          <a:p>
+            <a:pPr algn="ctr">
+              <a:lnSpc>
+                <a:spcPct val="150000"/>
+              </a:lnSpc>
+            </a:pPr>
+            <a:r>
+              <a:rPr lang="en-US" sz="2400" dirty="0">
+                <a:solidFill>
+                  <a:schemeClr val="accent6">
+                    <a:lumMod val="75000"/>
+                  </a:schemeClr>
+                </a:solidFill>
+                <a:latin typeface="Courier New" panose="02070309020205020404" pitchFamily="49" charset="0"/>
+              </a:rPr>
+              <a:t>if (</a:t>
+            </a:r>
+            <a:r>
+              <a:rPr lang="en-US" sz="2400" dirty="0" err="1">
+                <a:solidFill>
+                  <a:schemeClr val="accent6">
+                    <a:lumMod val="75000"/>
+                  </a:schemeClr>
+                </a:solidFill>
+                <a:latin typeface="Courier New" panose="02070309020205020404" pitchFamily="49" charset="0"/>
+              </a:rPr>
+              <a:t>open.contains</a:t>
+            </a:r>
+            <a:r>
+              <a:rPr lang="en-US" sz="2400" dirty="0">
+                <a:solidFill>
+                  <a:schemeClr val="accent6">
+                    <a:lumMod val="75000"/>
+                  </a:schemeClr>
+                </a:solidFill>
+                <a:latin typeface="Courier New" panose="02070309020205020404" pitchFamily="49" charset="0"/>
+              </a:rPr>
+              <a:t>(</a:t>
+            </a:r>
+            <a:r>
+              <a:rPr lang="en-US" sz="2400" dirty="0" err="1">
+                <a:solidFill>
+                  <a:schemeClr val="accent6">
+                    <a:lumMod val="75000"/>
+                  </a:schemeClr>
+                </a:solidFill>
+                <a:latin typeface="Courier New" panose="02070309020205020404" pitchFamily="49" charset="0"/>
+              </a:rPr>
+              <a:t>curr</a:t>
+            </a:r>
+            <a:r>
+              <a:rPr lang="en-US" sz="2400" dirty="0">
+                <a:solidFill>
+                  <a:schemeClr val="accent6">
+                    <a:lumMod val="75000"/>
+                  </a:schemeClr>
+                </a:solidFill>
+                <a:latin typeface="Courier New" panose="02070309020205020404" pitchFamily="49" charset="0"/>
+              </a:rPr>
+              <a:t>))</a:t>
+            </a:r>
+            <a:br>
+              <a:rPr lang="en-US" sz="2400" dirty="0">
+                <a:solidFill>
+                  <a:schemeClr val="accent6">
+                    <a:lumMod val="75000"/>
+                  </a:schemeClr>
+                </a:solidFill>
+                <a:latin typeface="Courier New" panose="02070309020205020404" pitchFamily="49" charset="0"/>
+              </a:rPr>
+            </a:br>
+            <a:r>
+              <a:rPr lang="en-US" sz="1800" dirty="0">
+                <a:solidFill>
+                  <a:schemeClr val="accent6">
+                    <a:lumMod val="75000"/>
+                  </a:schemeClr>
+                </a:solidFill>
+                <a:latin typeface="Courier New" panose="02070309020205020404" pitchFamily="49" charset="0"/>
+              </a:rPr>
+              <a:t>      </a:t>
+            </a:r>
+          </a:p>
+          <a:p>
+            <a:r>
+              <a:rPr lang="en-US" sz="2400" dirty="0">
+                <a:solidFill>
+                  <a:srgbClr val="000000"/>
+                </a:solidFill>
+                <a:latin typeface="Abadi" panose="020B0604020104020204" pitchFamily="34" charset="0"/>
+              </a:rPr>
+              <a:t>If current character is a closed symbol, check to see if it corresponds to the open symbol from the top of the stack:</a:t>
+            </a:r>
+          </a:p>
+          <a:p>
+            <a:pPr algn="ctr">
+              <a:lnSpc>
+                <a:spcPct val="150000"/>
+              </a:lnSpc>
+            </a:pPr>
+            <a:r>
+              <a:rPr lang="en-US" sz="2400" dirty="0" err="1">
+                <a:solidFill>
+                  <a:schemeClr val="accent6">
+                    <a:lumMod val="75000"/>
+                  </a:schemeClr>
+                </a:solidFill>
+                <a:latin typeface="Courier New" panose="02070309020205020404" pitchFamily="49" charset="0"/>
+              </a:rPr>
+              <a:t>closed.indexOf</a:t>
+            </a:r>
+            <a:r>
+              <a:rPr lang="en-US" sz="2400" dirty="0">
+                <a:solidFill>
+                  <a:schemeClr val="accent6">
+                    <a:lumMod val="75000"/>
+                  </a:schemeClr>
+                </a:solidFill>
+                <a:latin typeface="Courier New" panose="02070309020205020404" pitchFamily="49" charset="0"/>
+              </a:rPr>
+              <a:t>(</a:t>
+            </a:r>
+            <a:r>
+              <a:rPr lang="en-US" sz="2400" dirty="0" err="1">
+                <a:solidFill>
+                  <a:schemeClr val="accent6">
+                    <a:lumMod val="75000"/>
+                  </a:schemeClr>
+                </a:solidFill>
+                <a:latin typeface="Courier New" panose="02070309020205020404" pitchFamily="49" charset="0"/>
+              </a:rPr>
+              <a:t>curr</a:t>
+            </a:r>
+            <a:r>
+              <a:rPr lang="en-US" sz="2400" dirty="0">
+                <a:solidFill>
+                  <a:schemeClr val="accent6">
+                    <a:lumMod val="75000"/>
+                  </a:schemeClr>
+                </a:solidFill>
+                <a:latin typeface="Courier New" panose="02070309020205020404" pitchFamily="49" charset="0"/>
+              </a:rPr>
+              <a:t>)</a:t>
+            </a:r>
+            <a:r>
+              <a:rPr lang="en-US" sz="1200" dirty="0">
+                <a:solidFill>
+                  <a:schemeClr val="accent6">
+                    <a:lumMod val="75000"/>
+                  </a:schemeClr>
+                </a:solidFill>
+                <a:latin typeface="Courier New" panose="02070309020205020404" pitchFamily="49" charset="0"/>
+              </a:rPr>
+              <a:t> </a:t>
+            </a:r>
+            <a:r>
+              <a:rPr lang="en-US" sz="2400" dirty="0">
+                <a:solidFill>
+                  <a:schemeClr val="accent6">
+                    <a:lumMod val="75000"/>
+                  </a:schemeClr>
+                </a:solidFill>
+                <a:latin typeface="Courier New" panose="02070309020205020404" pitchFamily="49" charset="0"/>
+              </a:rPr>
+              <a:t>==</a:t>
+            </a:r>
+            <a:r>
+              <a:rPr lang="en-US" sz="1200" dirty="0">
+                <a:solidFill>
+                  <a:schemeClr val="accent6">
+                    <a:lumMod val="75000"/>
+                  </a:schemeClr>
+                </a:solidFill>
+                <a:latin typeface="Courier New" panose="02070309020205020404" pitchFamily="49" charset="0"/>
+              </a:rPr>
+              <a:t> </a:t>
+            </a:r>
+            <a:r>
+              <a:rPr lang="en-US" sz="2400" dirty="0" err="1">
+                <a:solidFill>
+                  <a:schemeClr val="accent6">
+                    <a:lumMod val="75000"/>
+                  </a:schemeClr>
+                </a:solidFill>
+                <a:latin typeface="Courier New" panose="02070309020205020404" pitchFamily="49" charset="0"/>
+              </a:rPr>
+              <a:t>open.indexOf</a:t>
+            </a:r>
+            <a:r>
+              <a:rPr lang="en-US" sz="2400" dirty="0">
+                <a:solidFill>
+                  <a:schemeClr val="accent6">
+                    <a:lumMod val="75000"/>
+                  </a:schemeClr>
+                </a:solidFill>
+                <a:latin typeface="Courier New" panose="02070309020205020404" pitchFamily="49" charset="0"/>
+              </a:rPr>
+              <a:t>(</a:t>
+            </a:r>
+            <a:r>
+              <a:rPr lang="en-US" sz="2400" dirty="0" err="1">
+                <a:solidFill>
+                  <a:schemeClr val="accent6">
+                    <a:lumMod val="75000"/>
+                  </a:schemeClr>
+                </a:solidFill>
+                <a:latin typeface="Courier New" panose="02070309020205020404" pitchFamily="49" charset="0"/>
+              </a:rPr>
+              <a:t>stack.pop</a:t>
+            </a:r>
+            <a:r>
+              <a:rPr lang="en-US" sz="2400" dirty="0">
+                <a:solidFill>
+                  <a:schemeClr val="accent6">
+                    <a:lumMod val="75000"/>
+                  </a:schemeClr>
+                </a:solidFill>
+                <a:latin typeface="Courier New" panose="02070309020205020404" pitchFamily="49" charset="0"/>
+              </a:rPr>
+              <a:t>())</a:t>
+            </a:r>
           </a:p>
         </p:txBody>
       </p:sp>
@@ -11615,8 +11501,8 @@
         </p:nvSpPr>
         <p:spPr>
           <a:xfrm>
-            <a:off x="266700" y="1373862"/>
-            <a:ext cx="8610600" cy="4832092"/>
+            <a:off x="266700" y="1143000"/>
+            <a:ext cx="8610600" cy="2677656"/>
           </a:xfrm>
           <a:prstGeom prst="rect">
             <a:avLst/>
@@ -11630,61 +11516,197 @@
           <a:lstStyle/>
           <a:p>
             <a:r>
-              <a:rPr lang="en-US" sz="2200" dirty="0">
-                <a:solidFill>
-                  <a:srgbClr val="941EDF"/>
-                </a:solidFill>
-                <a:latin typeface="Courier New" panose="02070309020205020404" pitchFamily="49" charset="0"/>
-              </a:rPr>
-              <a:t>public</a:t>
-            </a:r>
-            <a:r>
-              <a:rPr lang="en-US" sz="2200" dirty="0">
+              <a:rPr lang="en-US" sz="2400" dirty="0">
+                <a:latin typeface="Courier New" panose="02070309020205020404" pitchFamily="49" charset="0"/>
+              </a:rPr>
+              <a:t>public </a:t>
+            </a:r>
+            <a:r>
+              <a:rPr lang="en-US" sz="2400" dirty="0" err="1">
+                <a:latin typeface="Courier New" panose="02070309020205020404" pitchFamily="49" charset="0"/>
+              </a:rPr>
+              <a:t>boolean</a:t>
+            </a:r>
+            <a:r>
+              <a:rPr lang="en-US" sz="2400" dirty="0">
+                <a:latin typeface="Courier New" panose="02070309020205020404" pitchFamily="49" charset="0"/>
+              </a:rPr>
+              <a:t> </a:t>
+            </a:r>
+            <a:r>
+              <a:rPr lang="en-US" sz="2400" dirty="0" err="1">
+                <a:latin typeface="Courier New" panose="02070309020205020404" pitchFamily="49" charset="0"/>
+              </a:rPr>
+              <a:t>checkExpression</a:t>
+            </a:r>
+            <a:r>
+              <a:rPr lang="en-US" sz="2400" dirty="0">
+                <a:latin typeface="Courier New" panose="02070309020205020404" pitchFamily="49" charset="0"/>
+              </a:rPr>
+              <a:t>() {</a:t>
+            </a:r>
+            <a:br>
+              <a:rPr lang="en-US" sz="2400" dirty="0">
+                <a:latin typeface="Courier New" panose="02070309020205020404" pitchFamily="49" charset="0"/>
+              </a:rPr>
+            </a:br>
+            <a:r>
+              <a:rPr lang="en-US" sz="2400" dirty="0">
+                <a:latin typeface="Courier New" panose="02070309020205020404" pitchFamily="49" charset="0"/>
+              </a:rPr>
+              <a:t>   Stack&lt;String&gt; stack = new Stack</a:t>
+            </a:r>
+            <a:r>
+              <a:rPr lang="en-US" sz="2400" dirty="0">
                 <a:solidFill>
                   <a:srgbClr val="000000"/>
                 </a:solidFill>
                 <a:latin typeface="Courier New" panose="02070309020205020404" pitchFamily="49" charset="0"/>
               </a:rPr>
-              <a:t> </a:t>
-            </a:r>
-            <a:r>
-              <a:rPr lang="en-US" sz="2200" dirty="0" err="1">
-                <a:solidFill>
-                  <a:srgbClr val="941EDF"/>
-                </a:solidFill>
-                <a:latin typeface="Courier New" panose="02070309020205020404" pitchFamily="49" charset="0"/>
-              </a:rPr>
-              <a:t>boolean</a:t>
-            </a:r>
-            <a:r>
-              <a:rPr lang="en-US" sz="2200" dirty="0">
+              <a:t>&lt;&gt;();</a:t>
+            </a:r>
+            <a:br>
+              <a:rPr lang="en-US" sz="2400" dirty="0">
                 <a:solidFill>
                   <a:srgbClr val="000000"/>
                 </a:solidFill>
                 <a:latin typeface="Courier New" panose="02070309020205020404" pitchFamily="49" charset="0"/>
               </a:rPr>
-              <a:t> </a:t>
-            </a:r>
-            <a:r>
-              <a:rPr lang="en-US" sz="2200" dirty="0" err="1">
+            </a:br>
+            <a:r>
+              <a:rPr lang="en-US" sz="2400" dirty="0">
                 <a:solidFill>
                   <a:srgbClr val="000000"/>
                 </a:solidFill>
                 <a:latin typeface="Courier New" panose="02070309020205020404" pitchFamily="49" charset="0"/>
               </a:rPr>
-              <a:t>checkExpression</a:t>
-            </a:r>
-            <a:r>
-              <a:rPr lang="en-US" sz="2200" dirty="0">
+              <a:t>   </a:t>
+            </a:r>
+            <a:r>
+              <a:rPr lang="en-US" sz="2400" dirty="0">
+                <a:solidFill>
+                  <a:schemeClr val="accent6">
+                    <a:lumMod val="75000"/>
+                  </a:schemeClr>
+                </a:solidFill>
+                <a:latin typeface="Courier New" panose="02070309020205020404" pitchFamily="49" charset="0"/>
+              </a:rPr>
+              <a:t>Map&lt;</a:t>
+            </a:r>
+            <a:r>
+              <a:rPr lang="en-US" sz="2400" dirty="0" err="1">
+                <a:solidFill>
+                  <a:schemeClr val="accent6">
+                    <a:lumMod val="75000"/>
+                  </a:schemeClr>
+                </a:solidFill>
+                <a:latin typeface="Courier New" panose="02070309020205020404" pitchFamily="49" charset="0"/>
+              </a:rPr>
+              <a:t>String,String</a:t>
+            </a:r>
+            <a:r>
+              <a:rPr lang="en-US" sz="2400" dirty="0">
+                <a:solidFill>
+                  <a:schemeClr val="accent6">
+                    <a:lumMod val="75000"/>
+                  </a:schemeClr>
+                </a:solidFill>
+                <a:latin typeface="Courier New" panose="02070309020205020404" pitchFamily="49" charset="0"/>
+              </a:rPr>
+              <a:t>&gt; pairs = new HashMap&lt;&gt;();</a:t>
+            </a:r>
+            <a:br>
+              <a:rPr lang="en-US" sz="2400" dirty="0">
+                <a:solidFill>
+                  <a:schemeClr val="accent6">
+                    <a:lumMod val="75000"/>
+                  </a:schemeClr>
+                </a:solidFill>
+                <a:latin typeface="Courier New" panose="02070309020205020404" pitchFamily="49" charset="0"/>
+              </a:rPr>
+            </a:br>
+            <a:r>
+              <a:rPr lang="en-US" sz="2400" dirty="0">
+                <a:solidFill>
+                  <a:schemeClr val="accent6">
+                    <a:lumMod val="75000"/>
+                  </a:schemeClr>
+                </a:solidFill>
+                <a:latin typeface="Courier New" panose="02070309020205020404" pitchFamily="49" charset="0"/>
+              </a:rPr>
+              <a:t>   </a:t>
+            </a:r>
+            <a:r>
+              <a:rPr lang="en-US" sz="2400" dirty="0" err="1">
+                <a:solidFill>
+                  <a:schemeClr val="accent6">
+                    <a:lumMod val="75000"/>
+                  </a:schemeClr>
+                </a:solidFill>
+                <a:latin typeface="Courier New" panose="02070309020205020404" pitchFamily="49" charset="0"/>
+              </a:rPr>
+              <a:t>pairs.put</a:t>
+            </a:r>
+            <a:r>
+              <a:rPr lang="en-US" sz="2400" dirty="0">
+                <a:solidFill>
+                  <a:schemeClr val="accent6">
+                    <a:lumMod val="75000"/>
+                  </a:schemeClr>
+                </a:solidFill>
+                <a:latin typeface="Courier New" panose="02070309020205020404" pitchFamily="49" charset="0"/>
+              </a:rPr>
+              <a:t>(</a:t>
+            </a:r>
+            <a:r>
+              <a:rPr lang="en-US" sz="2400" dirty="0">
+                <a:solidFill>
+                  <a:srgbClr val="00A000"/>
+                </a:solidFill>
+                <a:latin typeface="Courier New" panose="02070309020205020404" pitchFamily="49" charset="0"/>
+              </a:rPr>
+              <a:t>"{"</a:t>
+            </a:r>
+            <a:r>
+              <a:rPr lang="en-US" sz="2400" dirty="0">
                 <a:solidFill>
                   <a:srgbClr val="000000"/>
                 </a:solidFill>
                 <a:latin typeface="Courier New" panose="02070309020205020404" pitchFamily="49" charset="0"/>
               </a:rPr>
-              <a:t>() {</a:t>
+              <a:t>, </a:t>
+            </a:r>
+            <a:r>
+              <a:rPr lang="en-US" sz="2400" dirty="0">
+                <a:solidFill>
+                  <a:srgbClr val="00A000"/>
+                </a:solidFill>
+                <a:latin typeface="Courier New" panose="02070309020205020404" pitchFamily="49" charset="0"/>
+              </a:rPr>
+              <a:t>"}"</a:t>
+            </a:r>
+            <a:r>
+              <a:rPr lang="en-US" sz="2400" dirty="0">
+                <a:solidFill>
+                  <a:schemeClr val="accent6">
+                    <a:lumMod val="75000"/>
+                  </a:schemeClr>
+                </a:solidFill>
+                <a:latin typeface="Courier New" panose="02070309020205020404" pitchFamily="49" charset="0"/>
+              </a:rPr>
+              <a:t>)</a:t>
+            </a:r>
+            <a:r>
+              <a:rPr lang="en-US" sz="2400" dirty="0">
+                <a:solidFill>
+                  <a:srgbClr val="000000"/>
+                </a:solidFill>
+                <a:latin typeface="Courier New" panose="02070309020205020404" pitchFamily="49" charset="0"/>
+              </a:rPr>
+              <a:t>;</a:t>
             </a:r>
             <a:br>
-              <a:rPr lang="en-US" sz="2200" dirty="0">
+              <a:rPr lang="en-US" sz="2400" dirty="0">
                 <a:solidFill>
                   <a:srgbClr val="000000"/>
                 </a:solidFill>
@@ -11692,45 +11714,85 @@
               </a:rPr>
             </a:br>
             <a:r>
-              <a:rPr lang="en-US" sz="2200" dirty="0">
+              <a:rPr lang="en-US" sz="2400" dirty="0">
                 <a:solidFill>
                   <a:srgbClr val="000000"/>
                 </a:solidFill>
                 <a:latin typeface="Courier New" panose="02070309020205020404" pitchFamily="49" charset="0"/>
               </a:rPr>
-              <a:t>   Stack&lt;String&gt; symbols;</a:t>
-            </a:r>
-          </a:p>
-          <a:p>
-            <a:r>
-              <a:rPr lang="en-US" sz="2200" dirty="0">
+              <a:t>   </a:t>
+            </a:r>
+            <a:r>
+              <a:rPr lang="en-US" sz="2400" dirty="0" err="1">
+                <a:solidFill>
+                  <a:schemeClr val="accent6">
+                    <a:lumMod val="75000"/>
+                  </a:schemeClr>
+                </a:solidFill>
+                <a:latin typeface="Courier New" panose="02070309020205020404" pitchFamily="49" charset="0"/>
+              </a:rPr>
+              <a:t>pairs.put</a:t>
+            </a:r>
+            <a:r>
+              <a:rPr lang="en-US" sz="2400" dirty="0">
+                <a:solidFill>
+                  <a:schemeClr val="accent6">
+                    <a:lumMod val="75000"/>
+                  </a:schemeClr>
+                </a:solidFill>
+                <a:latin typeface="Courier New" panose="02070309020205020404" pitchFamily="49" charset="0"/>
+              </a:rPr>
+              <a:t>(</a:t>
+            </a:r>
+            <a:r>
+              <a:rPr lang="en-US" sz="2400" dirty="0">
+                <a:solidFill>
+                  <a:srgbClr val="00A000"/>
+                </a:solidFill>
+                <a:latin typeface="Courier New" panose="02070309020205020404" pitchFamily="49" charset="0"/>
+              </a:rPr>
+              <a:t>"("</a:t>
+            </a:r>
+            <a:r>
+              <a:rPr lang="en-US" sz="2400" dirty="0">
                 <a:solidFill>
                   <a:srgbClr val="000000"/>
                 </a:solidFill>
                 <a:latin typeface="Courier New" panose="02070309020205020404" pitchFamily="49" charset="0"/>
               </a:rPr>
-              <a:t>   symbols = </a:t>
-            </a:r>
-            <a:r>
-              <a:rPr lang="en-US" sz="2200" dirty="0">
-                <a:solidFill>
-                  <a:srgbClr val="941EDF"/>
-                </a:solidFill>
-                <a:latin typeface="Courier New" panose="02070309020205020404" pitchFamily="49" charset="0"/>
-              </a:rPr>
-              <a:t>new</a:t>
-            </a:r>
-            <a:r>
-              <a:rPr lang="en-US" sz="2200" dirty="0">
+              <a:t>, </a:t>
+            </a:r>
+            <a:r>
+              <a:rPr lang="en-US" sz="2400" dirty="0">
+                <a:solidFill>
+                  <a:srgbClr val="00A000"/>
+                </a:solidFill>
+                <a:latin typeface="Courier New" panose="02070309020205020404" pitchFamily="49" charset="0"/>
+              </a:rPr>
+              <a:t>")"</a:t>
+            </a:r>
+            <a:r>
+              <a:rPr lang="en-US" sz="2400" dirty="0">
+                <a:solidFill>
+                  <a:schemeClr val="accent6">
+                    <a:lumMod val="75000"/>
+                  </a:schemeClr>
+                </a:solidFill>
+                <a:latin typeface="Courier New" panose="02070309020205020404" pitchFamily="49" charset="0"/>
+              </a:rPr>
+              <a:t>)</a:t>
+            </a:r>
+            <a:r>
+              <a:rPr lang="en-US" sz="2400" dirty="0">
                 <a:solidFill>
                   <a:srgbClr val="000000"/>
                 </a:solidFill>
                 <a:latin typeface="Courier New" panose="02070309020205020404" pitchFamily="49" charset="0"/>
               </a:rPr>
-              <a:t> Stack&lt;String&gt;();</a:t>
+              <a:t>;</a:t>
             </a:r>
             <a:br>
-              <a:rPr lang="en-US" sz="2200" dirty="0">
+              <a:rPr lang="en-US" sz="2400" dirty="0">
                 <a:solidFill>
                   <a:srgbClr val="000000"/>
                 </a:solidFill>
@@ -11738,34 +11800,85 @@
               </a:rPr>
             </a:br>
             <a:r>
-              <a:rPr lang="en-US" sz="2200" dirty="0">
+              <a:rPr lang="en-US" sz="2400" dirty="0">
                 <a:solidFill>
                   <a:srgbClr val="000000"/>
                 </a:solidFill>
                 <a:latin typeface="Courier New" panose="02070309020205020404" pitchFamily="49" charset="0"/>
               </a:rPr>
-              <a:t>   Map&lt;</a:t>
-            </a:r>
-            <a:r>
-              <a:rPr lang="en-US" sz="2200" dirty="0" err="1">
+              <a:t>   </a:t>
+            </a:r>
+            <a:r>
+              <a:rPr lang="en-US" sz="2400" dirty="0" err="1">
+                <a:solidFill>
+                  <a:schemeClr val="accent6">
+                    <a:lumMod val="75000"/>
+                  </a:schemeClr>
+                </a:solidFill>
+                <a:latin typeface="Courier New" panose="02070309020205020404" pitchFamily="49" charset="0"/>
+              </a:rPr>
+              <a:t>pairs.put</a:t>
+            </a:r>
+            <a:r>
+              <a:rPr lang="en-US" sz="2400" dirty="0">
+                <a:solidFill>
+                  <a:schemeClr val="accent6">
+                    <a:lumMod val="75000"/>
+                  </a:schemeClr>
+                </a:solidFill>
+                <a:latin typeface="Courier New" panose="02070309020205020404" pitchFamily="49" charset="0"/>
+              </a:rPr>
+              <a:t>(</a:t>
+            </a:r>
+            <a:r>
+              <a:rPr lang="en-US" sz="2400" dirty="0">
+                <a:solidFill>
+                  <a:srgbClr val="00A000"/>
+                </a:solidFill>
+                <a:latin typeface="Courier New" panose="02070309020205020404" pitchFamily="49" charset="0"/>
+              </a:rPr>
+              <a:t>"&lt;"</a:t>
+            </a:r>
+            <a:r>
+              <a:rPr lang="en-US" sz="2400" dirty="0">
                 <a:solidFill>
                   <a:srgbClr val="000000"/>
                 </a:solidFill>
                 <a:latin typeface="Courier New" panose="02070309020205020404" pitchFamily="49" charset="0"/>
               </a:rPr>
-              <a:t>String,String</a:t>
-            </a:r>
-            <a:r>
-              <a:rPr lang="en-US" sz="2200" dirty="0">
+              <a:t>, </a:t>
+            </a:r>
+            <a:r>
+              <a:rPr lang="en-US" sz="2400" dirty="0">
+                <a:solidFill>
+                  <a:srgbClr val="00A000"/>
+                </a:solidFill>
+                <a:latin typeface="Courier New" panose="02070309020205020404" pitchFamily="49" charset="0"/>
+              </a:rPr>
+              <a:t>"&gt;"</a:t>
+            </a:r>
+            <a:r>
+              <a:rPr lang="en-US" sz="2400" dirty="0">
+                <a:solidFill>
+                  <a:schemeClr val="accent6">
+                    <a:lumMod val="75000"/>
+                  </a:schemeClr>
+                </a:solidFill>
+                <a:latin typeface="Courier New" panose="02070309020205020404" pitchFamily="49" charset="0"/>
+              </a:rPr>
+              <a:t>)</a:t>
+            </a:r>
+            <a:r>
+              <a:rPr lang="en-US" sz="2400" dirty="0">
                 <a:solidFill>
                   <a:srgbClr val="000000"/>
                 </a:solidFill>
                 <a:latin typeface="Courier New" panose="02070309020205020404" pitchFamily="49" charset="0"/>
               </a:rPr>
-              <a:t>&gt; pairs;</a:t>
+              <a:t>;</a:t>
             </a:r>
             <a:br>
-              <a:rPr lang="en-US" sz="2200" dirty="0">
+              <a:rPr lang="en-US" sz="2400" dirty="0">
                 <a:solidFill>
                   <a:srgbClr val="000000"/>
                 </a:solidFill>
@@ -11773,495 +11886,84 @@
               </a:rPr>
             </a:br>
             <a:r>
-              <a:rPr lang="en-US" sz="2200" dirty="0">
+              <a:rPr lang="en-US" sz="2400" dirty="0">
                 <a:solidFill>
                   <a:srgbClr val="000000"/>
                 </a:solidFill>
                 <a:latin typeface="Courier New" panose="02070309020205020404" pitchFamily="49" charset="0"/>
               </a:rPr>
-              <a:t>   pairs = </a:t>
-            </a:r>
-            <a:r>
-              <a:rPr lang="en-US" sz="2200" dirty="0">
-                <a:solidFill>
-                  <a:srgbClr val="941EDF"/>
-                </a:solidFill>
-                <a:latin typeface="Courier New" panose="02070309020205020404" pitchFamily="49" charset="0"/>
-              </a:rPr>
-              <a:t>new</a:t>
-            </a:r>
-            <a:r>
-              <a:rPr lang="en-US" sz="2200" dirty="0">
+              <a:t>   </a:t>
+            </a:r>
+            <a:r>
+              <a:rPr lang="en-US" sz="2400" dirty="0" err="1">
+                <a:solidFill>
+                  <a:schemeClr val="accent6">
+                    <a:lumMod val="75000"/>
+                  </a:schemeClr>
+                </a:solidFill>
+                <a:latin typeface="Courier New" panose="02070309020205020404" pitchFamily="49" charset="0"/>
+              </a:rPr>
+              <a:t>pairs.put</a:t>
+            </a:r>
+            <a:r>
+              <a:rPr lang="en-US" sz="2400" dirty="0">
+                <a:solidFill>
+                  <a:schemeClr val="accent6">
+                    <a:lumMod val="75000"/>
+                  </a:schemeClr>
+                </a:solidFill>
+                <a:latin typeface="Courier New" panose="02070309020205020404" pitchFamily="49" charset="0"/>
+              </a:rPr>
+              <a:t>(</a:t>
+            </a:r>
+            <a:r>
+              <a:rPr lang="en-US" sz="2400" dirty="0">
+                <a:solidFill>
+                  <a:srgbClr val="00A000"/>
+                </a:solidFill>
+                <a:latin typeface="Courier New" panose="02070309020205020404" pitchFamily="49" charset="0"/>
+              </a:rPr>
+              <a:t>"["</a:t>
+            </a:r>
+            <a:r>
+              <a:rPr lang="en-US" sz="2400" dirty="0">
                 <a:solidFill>
                   <a:srgbClr val="000000"/>
                 </a:solidFill>
                 <a:latin typeface="Courier New" panose="02070309020205020404" pitchFamily="49" charset="0"/>
               </a:rPr>
-              <a:t> HashMap&lt;</a:t>
-            </a:r>
-            <a:r>
-              <a:rPr lang="en-US" sz="2200" dirty="0" err="1">
+              <a:t>, </a:t>
+            </a:r>
+            <a:r>
+              <a:rPr lang="en-US" sz="2400" dirty="0">
+                <a:solidFill>
+                  <a:srgbClr val="00A000"/>
+                </a:solidFill>
+                <a:latin typeface="Courier New" panose="02070309020205020404" pitchFamily="49" charset="0"/>
+              </a:rPr>
+              <a:t>"]"</a:t>
+            </a:r>
+            <a:r>
+              <a:rPr lang="en-US" sz="2400" dirty="0">
+                <a:solidFill>
+                  <a:schemeClr val="accent6">
+                    <a:lumMod val="75000"/>
+                  </a:schemeClr>
+                </a:solidFill>
+                <a:latin typeface="Courier New" panose="02070309020205020404" pitchFamily="49" charset="0"/>
+              </a:rPr>
+              <a:t>)</a:t>
+            </a:r>
+            <a:r>
+              <a:rPr lang="en-US" sz="2400" dirty="0">
                 <a:solidFill>
                   <a:srgbClr val="000000"/>
                 </a:solidFill>
                 <a:latin typeface="Courier New" panose="02070309020205020404" pitchFamily="49" charset="0"/>
               </a:rPr>
-              <a:t>String,String</a:t>
-            </a:r>
-            <a:r>
-              <a:rPr lang="en-US" sz="2200" dirty="0">
-                <a:solidFill>
-                  <a:srgbClr val="000000"/>
-                </a:solidFill>
-                <a:latin typeface="Courier New" panose="02070309020205020404" pitchFamily="49" charset="0"/>
-              </a:rPr>
-              <a:t>&gt;();</a:t>
-            </a:r>
-            <a:br>
-              <a:rPr lang="en-US" sz="2200" dirty="0">
-                <a:solidFill>
-                  <a:srgbClr val="000000"/>
-                </a:solidFill>
-                <a:latin typeface="Courier New" panose="02070309020205020404" pitchFamily="49" charset="0"/>
-              </a:rPr>
-            </a:br>
-            <a:r>
-              <a:rPr lang="en-US" sz="2200" dirty="0">
-                <a:solidFill>
-                  <a:srgbClr val="000000"/>
-                </a:solidFill>
-                <a:latin typeface="Courier New" panose="02070309020205020404" pitchFamily="49" charset="0"/>
-              </a:rPr>
-              <a:t>   </a:t>
-            </a:r>
-            <a:r>
-              <a:rPr lang="en-US" sz="2200" dirty="0" err="1">
-                <a:solidFill>
-                  <a:srgbClr val="000000"/>
-                </a:solidFill>
-                <a:latin typeface="Courier New" panose="02070309020205020404" pitchFamily="49" charset="0"/>
-              </a:rPr>
-              <a:t>pairs.put</a:t>
-            </a:r>
-            <a:r>
-              <a:rPr lang="en-US" sz="2200" dirty="0">
-                <a:solidFill>
-                  <a:srgbClr val="000000"/>
-                </a:solidFill>
-                <a:latin typeface="Courier New" panose="02070309020205020404" pitchFamily="49" charset="0"/>
-              </a:rPr>
-              <a:t>(</a:t>
-            </a:r>
-            <a:r>
-              <a:rPr lang="en-US" sz="2200" dirty="0">
-                <a:solidFill>
-                  <a:srgbClr val="00A000"/>
-                </a:solidFill>
-                <a:latin typeface="Courier New" panose="02070309020205020404" pitchFamily="49" charset="0"/>
-              </a:rPr>
-              <a:t>"{"</a:t>
-            </a:r>
-            <a:r>
-              <a:rPr lang="en-US" sz="2200" dirty="0">
-                <a:solidFill>
-                  <a:srgbClr val="000000"/>
-                </a:solidFill>
-                <a:latin typeface="Courier New" panose="02070309020205020404" pitchFamily="49" charset="0"/>
-              </a:rPr>
-              <a:t>,</a:t>
-            </a:r>
-            <a:r>
-              <a:rPr lang="en-US" sz="2200" dirty="0">
-                <a:solidFill>
-                  <a:srgbClr val="00A000"/>
-                </a:solidFill>
-                <a:latin typeface="Courier New" panose="02070309020205020404" pitchFamily="49" charset="0"/>
-              </a:rPr>
-              <a:t>"}"</a:t>
-            </a:r>
-            <a:r>
-              <a:rPr lang="en-US" sz="2200" dirty="0">
-                <a:solidFill>
-                  <a:srgbClr val="000000"/>
-                </a:solidFill>
-                <a:latin typeface="Courier New" panose="02070309020205020404" pitchFamily="49" charset="0"/>
-              </a:rPr>
-              <a:t>);</a:t>
-            </a:r>
-            <a:br>
-              <a:rPr lang="en-US" sz="2200" dirty="0">
-                <a:solidFill>
-                  <a:srgbClr val="000000"/>
-                </a:solidFill>
-                <a:latin typeface="Courier New" panose="02070309020205020404" pitchFamily="49" charset="0"/>
-              </a:rPr>
-            </a:br>
-            <a:r>
-              <a:rPr lang="en-US" sz="2200" dirty="0">
-                <a:solidFill>
-                  <a:srgbClr val="000000"/>
-                </a:solidFill>
-                <a:latin typeface="Courier New" panose="02070309020205020404" pitchFamily="49" charset="0"/>
-              </a:rPr>
-              <a:t>   </a:t>
-            </a:r>
-            <a:r>
-              <a:rPr lang="en-US" sz="2200" dirty="0" err="1">
-                <a:solidFill>
-                  <a:srgbClr val="000000"/>
-                </a:solidFill>
-                <a:latin typeface="Courier New" panose="02070309020205020404" pitchFamily="49" charset="0"/>
-              </a:rPr>
-              <a:t>pairs.put</a:t>
-            </a:r>
-            <a:r>
-              <a:rPr lang="en-US" sz="2200" dirty="0">
-                <a:solidFill>
-                  <a:srgbClr val="000000"/>
-                </a:solidFill>
-                <a:latin typeface="Courier New" panose="02070309020205020404" pitchFamily="49" charset="0"/>
-              </a:rPr>
-              <a:t>(</a:t>
-            </a:r>
-            <a:r>
-              <a:rPr lang="en-US" sz="2200" dirty="0">
-                <a:solidFill>
-                  <a:srgbClr val="00A000"/>
-                </a:solidFill>
-                <a:latin typeface="Courier New" panose="02070309020205020404" pitchFamily="49" charset="0"/>
-              </a:rPr>
-              <a:t>"("</a:t>
-            </a:r>
-            <a:r>
-              <a:rPr lang="en-US" sz="2200" dirty="0">
-                <a:solidFill>
-                  <a:srgbClr val="000000"/>
-                </a:solidFill>
-                <a:latin typeface="Courier New" panose="02070309020205020404" pitchFamily="49" charset="0"/>
-              </a:rPr>
-              <a:t>,</a:t>
-            </a:r>
-            <a:r>
-              <a:rPr lang="en-US" sz="2200" dirty="0">
-                <a:solidFill>
-                  <a:srgbClr val="00A000"/>
-                </a:solidFill>
-                <a:latin typeface="Courier New" panose="02070309020205020404" pitchFamily="49" charset="0"/>
-              </a:rPr>
-              <a:t>")"</a:t>
-            </a:r>
-            <a:r>
-              <a:rPr lang="en-US" sz="2200" dirty="0">
-                <a:solidFill>
-                  <a:srgbClr val="000000"/>
-                </a:solidFill>
-                <a:latin typeface="Courier New" panose="02070309020205020404" pitchFamily="49" charset="0"/>
-              </a:rPr>
-              <a:t>);</a:t>
-            </a:r>
-            <a:br>
-              <a:rPr lang="en-US" sz="2200" dirty="0">
-                <a:solidFill>
-                  <a:srgbClr val="000000"/>
-                </a:solidFill>
-                <a:latin typeface="Courier New" panose="02070309020205020404" pitchFamily="49" charset="0"/>
-              </a:rPr>
-            </a:br>
-            <a:r>
-              <a:rPr lang="en-US" sz="2200" dirty="0">
-                <a:solidFill>
-                  <a:srgbClr val="000000"/>
-                </a:solidFill>
-                <a:latin typeface="Courier New" panose="02070309020205020404" pitchFamily="49" charset="0"/>
-              </a:rPr>
-              <a:t>   </a:t>
-            </a:r>
-            <a:r>
-              <a:rPr lang="en-US" sz="2200" dirty="0" err="1">
-                <a:solidFill>
-                  <a:srgbClr val="000000"/>
-                </a:solidFill>
-                <a:latin typeface="Courier New" panose="02070309020205020404" pitchFamily="49" charset="0"/>
-              </a:rPr>
-              <a:t>pairs.put</a:t>
-            </a:r>
-            <a:r>
-              <a:rPr lang="en-US" sz="2200" dirty="0">
-                <a:solidFill>
-                  <a:srgbClr val="000000"/>
-                </a:solidFill>
-                <a:latin typeface="Courier New" panose="02070309020205020404" pitchFamily="49" charset="0"/>
-              </a:rPr>
-              <a:t>(</a:t>
-            </a:r>
-            <a:r>
-              <a:rPr lang="en-US" sz="2200" dirty="0">
-                <a:solidFill>
-                  <a:srgbClr val="00A000"/>
-                </a:solidFill>
-                <a:latin typeface="Courier New" panose="02070309020205020404" pitchFamily="49" charset="0"/>
-              </a:rPr>
-              <a:t>"&lt;"</a:t>
-            </a:r>
-            <a:r>
-              <a:rPr lang="en-US" sz="2200" dirty="0">
-                <a:solidFill>
-                  <a:srgbClr val="000000"/>
-                </a:solidFill>
-                <a:latin typeface="Courier New" panose="02070309020205020404" pitchFamily="49" charset="0"/>
-              </a:rPr>
-              <a:t>,</a:t>
-            </a:r>
-            <a:r>
-              <a:rPr lang="en-US" sz="2200" dirty="0">
-                <a:solidFill>
-                  <a:srgbClr val="00A000"/>
-                </a:solidFill>
-                <a:latin typeface="Courier New" panose="02070309020205020404" pitchFamily="49" charset="0"/>
-              </a:rPr>
-              <a:t>"&gt;"</a:t>
-            </a:r>
-            <a:r>
-              <a:rPr lang="en-US" sz="2200" dirty="0">
-                <a:solidFill>
-                  <a:srgbClr val="000000"/>
-                </a:solidFill>
-                <a:latin typeface="Courier New" panose="02070309020205020404" pitchFamily="49" charset="0"/>
-              </a:rPr>
-              <a:t>);</a:t>
-            </a:r>
-            <a:br>
-              <a:rPr lang="en-US" sz="2200" dirty="0">
-                <a:solidFill>
-                  <a:srgbClr val="000000"/>
-                </a:solidFill>
-                <a:latin typeface="Courier New" panose="02070309020205020404" pitchFamily="49" charset="0"/>
-              </a:rPr>
-            </a:br>
-            <a:r>
-              <a:rPr lang="en-US" sz="2200" dirty="0">
-                <a:solidFill>
-                  <a:srgbClr val="000000"/>
-                </a:solidFill>
-                <a:latin typeface="Courier New" panose="02070309020205020404" pitchFamily="49" charset="0"/>
-              </a:rPr>
-              <a:t>   </a:t>
-            </a:r>
-            <a:r>
-              <a:rPr lang="en-US" sz="2200" dirty="0" err="1">
-                <a:solidFill>
-                  <a:srgbClr val="000000"/>
-                </a:solidFill>
-                <a:latin typeface="Courier New" panose="02070309020205020404" pitchFamily="49" charset="0"/>
-              </a:rPr>
-              <a:t>pairs.put</a:t>
-            </a:r>
-            <a:r>
-              <a:rPr lang="en-US" sz="2200" dirty="0">
-                <a:solidFill>
-                  <a:srgbClr val="000000"/>
-                </a:solidFill>
-                <a:latin typeface="Courier New" panose="02070309020205020404" pitchFamily="49" charset="0"/>
-              </a:rPr>
-              <a:t>(</a:t>
-            </a:r>
-            <a:r>
-              <a:rPr lang="en-US" sz="2200" dirty="0">
-                <a:solidFill>
-                  <a:srgbClr val="00A000"/>
-                </a:solidFill>
-                <a:latin typeface="Courier New" panose="02070309020205020404" pitchFamily="49" charset="0"/>
-              </a:rPr>
-              <a:t>"["</a:t>
-            </a:r>
-            <a:r>
-              <a:rPr lang="en-US" sz="2200" dirty="0">
-                <a:solidFill>
-                  <a:srgbClr val="000000"/>
-                </a:solidFill>
-                <a:latin typeface="Courier New" panose="02070309020205020404" pitchFamily="49" charset="0"/>
-              </a:rPr>
-              <a:t>,</a:t>
-            </a:r>
-            <a:r>
-              <a:rPr lang="en-US" sz="2200" dirty="0">
-                <a:solidFill>
-                  <a:srgbClr val="00A000"/>
-                </a:solidFill>
-                <a:latin typeface="Courier New" panose="02070309020205020404" pitchFamily="49" charset="0"/>
-              </a:rPr>
-              <a:t>"]"</a:t>
-            </a:r>
-            <a:r>
-              <a:rPr lang="en-US" sz="2200" dirty="0">
-                <a:solidFill>
-                  <a:srgbClr val="000000"/>
-                </a:solidFill>
-                <a:latin typeface="Courier New" panose="02070309020205020404" pitchFamily="49" charset="0"/>
-              </a:rPr>
-              <a:t>);</a:t>
-            </a:r>
-            <a:br>
-              <a:rPr lang="en-US" sz="2200" dirty="0">
-                <a:solidFill>
-                  <a:srgbClr val="000000"/>
-                </a:solidFill>
-                <a:latin typeface="Courier New" panose="02070309020205020404" pitchFamily="49" charset="0"/>
-              </a:rPr>
-            </a:br>
-            <a:br>
-              <a:rPr lang="en-US" sz="2200" dirty="0">
-                <a:solidFill>
-                  <a:srgbClr val="000000"/>
-                </a:solidFill>
-                <a:latin typeface="Courier New" panose="02070309020205020404" pitchFamily="49" charset="0"/>
-              </a:rPr>
-            </a:br>
-            <a:r>
-              <a:rPr lang="en-US" sz="2200" dirty="0">
-                <a:solidFill>
-                  <a:srgbClr val="000000"/>
-                </a:solidFill>
-                <a:latin typeface="Courier New" panose="02070309020205020404" pitchFamily="49" charset="0"/>
-              </a:rPr>
-              <a:t>   </a:t>
-            </a:r>
-            <a:r>
-              <a:rPr lang="en-US" sz="2200" dirty="0">
-                <a:solidFill>
-                  <a:srgbClr val="941EDF"/>
-                </a:solidFill>
-                <a:latin typeface="Courier New" panose="02070309020205020404" pitchFamily="49" charset="0"/>
-              </a:rPr>
-              <a:t>for</a:t>
-            </a:r>
-            <a:r>
-              <a:rPr lang="en-US" sz="2200" dirty="0">
-                <a:solidFill>
-                  <a:srgbClr val="000000"/>
-                </a:solidFill>
-                <a:latin typeface="Courier New" panose="02070309020205020404" pitchFamily="49" charset="0"/>
-              </a:rPr>
-              <a:t>(</a:t>
-            </a:r>
-            <a:r>
-              <a:rPr lang="en-US" sz="2200" dirty="0">
-                <a:solidFill>
-                  <a:srgbClr val="941EDF"/>
-                </a:solidFill>
-                <a:latin typeface="Courier New" panose="02070309020205020404" pitchFamily="49" charset="0"/>
-              </a:rPr>
-              <a:t>int</a:t>
-            </a:r>
-            <a:r>
-              <a:rPr lang="en-US" sz="2200" dirty="0">
-                <a:solidFill>
-                  <a:srgbClr val="000000"/>
-                </a:solidFill>
-                <a:latin typeface="Courier New" panose="02070309020205020404" pitchFamily="49" charset="0"/>
-              </a:rPr>
-              <a:t> i=0; i &lt; </a:t>
-            </a:r>
-            <a:r>
-              <a:rPr lang="en-US" sz="2200" dirty="0" err="1">
-                <a:solidFill>
-                  <a:srgbClr val="000000"/>
-                </a:solidFill>
-                <a:latin typeface="Courier New" panose="02070309020205020404" pitchFamily="49" charset="0"/>
-              </a:rPr>
-              <a:t>expression.length</a:t>
-            </a:r>
-            <a:r>
-              <a:rPr lang="en-US" sz="2200" dirty="0">
-                <a:solidFill>
-                  <a:srgbClr val="000000"/>
-                </a:solidFill>
-                <a:latin typeface="Courier New" panose="02070309020205020404" pitchFamily="49" charset="0"/>
-              </a:rPr>
-              <a:t>();  i++) </a:t>
-            </a:r>
-            <a:br>
-              <a:rPr lang="en-US" sz="2200" dirty="0">
-                <a:solidFill>
-                  <a:srgbClr val="000000"/>
-                </a:solidFill>
-                <a:latin typeface="Courier New" panose="02070309020205020404" pitchFamily="49" charset="0"/>
-              </a:rPr>
-            </a:br>
-            <a:r>
-              <a:rPr lang="en-US" sz="2200" dirty="0">
-                <a:solidFill>
-                  <a:srgbClr val="000000"/>
-                </a:solidFill>
-                <a:latin typeface="Courier New" panose="02070309020205020404" pitchFamily="49" charset="0"/>
-              </a:rPr>
-              <a:t>   {</a:t>
-            </a:r>
-            <a:br>
-              <a:rPr lang="en-US" sz="2200" dirty="0">
-                <a:solidFill>
-                  <a:srgbClr val="000000"/>
-                </a:solidFill>
-                <a:latin typeface="Courier New" panose="02070309020205020404" pitchFamily="49" charset="0"/>
-              </a:rPr>
-            </a:br>
-            <a:r>
-              <a:rPr lang="en-US" sz="2200" dirty="0">
-                <a:solidFill>
-                  <a:srgbClr val="000000"/>
-                </a:solidFill>
-                <a:latin typeface="Courier New" panose="02070309020205020404" pitchFamily="49" charset="0"/>
-              </a:rPr>
-              <a:t>      String </a:t>
-            </a:r>
-            <a:r>
-              <a:rPr lang="en-US" sz="2200" dirty="0" err="1">
-                <a:solidFill>
-                  <a:srgbClr val="000000"/>
-                </a:solidFill>
-                <a:latin typeface="Courier New" panose="02070309020205020404" pitchFamily="49" charset="0"/>
-              </a:rPr>
-              <a:t>curr</a:t>
-            </a:r>
-            <a:r>
-              <a:rPr lang="en-US" sz="2200" dirty="0">
-                <a:solidFill>
-                  <a:srgbClr val="000000"/>
-                </a:solidFill>
-                <a:latin typeface="Courier New" panose="02070309020205020404" pitchFamily="49" charset="0"/>
-              </a:rPr>
-              <a:t> = </a:t>
-            </a:r>
-            <a:r>
-              <a:rPr lang="en-US" sz="2200" dirty="0" err="1">
-                <a:solidFill>
-                  <a:srgbClr val="000000"/>
-                </a:solidFill>
-                <a:latin typeface="Courier New" panose="02070309020205020404" pitchFamily="49" charset="0"/>
-              </a:rPr>
-              <a:t>expression.substring</a:t>
-            </a:r>
-            <a:r>
-              <a:rPr lang="en-US" sz="2200" dirty="0">
-                <a:solidFill>
-                  <a:srgbClr val="000000"/>
-                </a:solidFill>
-                <a:latin typeface="Courier New" panose="02070309020205020404" pitchFamily="49" charset="0"/>
-              </a:rPr>
-              <a:t>(i,i+1);</a:t>
-            </a:r>
-          </a:p>
-          <a:p>
-            <a:r>
-              <a:rPr lang="en-US" sz="2200" dirty="0">
-                <a:solidFill>
-                  <a:srgbClr val="000000"/>
-                </a:solidFill>
-                <a:latin typeface="Courier New" panose="02070309020205020404" pitchFamily="49" charset="0"/>
-              </a:rPr>
-              <a:t>      </a:t>
-            </a:r>
-            <a:endParaRPr lang="en-US" sz="2200" dirty="0"/>
+              <a:t>;</a:t>
+            </a:r>
+            <a:endParaRPr lang="en-US" sz="2400" dirty="0"/>
           </a:p>
         </p:txBody>
       </p:sp>
@@ -12479,10 +12181,1051 @@
           </a:p>
         </p:txBody>
       </p:sp>
+      <p:sp>
+        <p:nvSpPr>
+          <p:cNvPr id="2" name="TextBox 1">
+            <a:extLst>
+              <a:ext uri="{FF2B5EF4-FFF2-40B4-BE49-F238E27FC236}">
+                <a16:creationId xmlns:a16="http://schemas.microsoft.com/office/drawing/2014/main" id="{B7B2CCCA-6882-2E9E-8A77-C96FC9392137}"/>
+              </a:ext>
+            </a:extLst>
+          </p:cNvPr>
+          <p:cNvSpPr txBox="1"/>
+          <p:nvPr/>
+        </p:nvSpPr>
+        <p:spPr>
+          <a:xfrm>
+            <a:off x="0" y="4092476"/>
+            <a:ext cx="9144000" cy="2308324"/>
+          </a:xfrm>
+          <a:prstGeom prst="rect">
+            <a:avLst/>
+          </a:prstGeom>
+          <a:noFill/>
+        </p:spPr>
+        <p:txBody>
+          <a:bodyPr wrap="square">
+            <a:spAutoFit/>
+          </a:bodyPr>
+          <a:lstStyle/>
+          <a:p>
+            <a:r>
+              <a:rPr lang="en-US" sz="2400" dirty="0">
+                <a:solidFill>
+                  <a:srgbClr val="000000"/>
+                </a:solidFill>
+                <a:latin typeface="Abadi" panose="020B0604020104020204" pitchFamily="34" charset="0"/>
+              </a:rPr>
+              <a:t>Check to see if current character is an open symbol: </a:t>
+            </a:r>
+          </a:p>
+          <a:p>
+            <a:pPr algn="ctr">
+              <a:lnSpc>
+                <a:spcPct val="150000"/>
+              </a:lnSpc>
+            </a:pPr>
+            <a:r>
+              <a:rPr lang="en-US" sz="2400" dirty="0">
+                <a:solidFill>
+                  <a:schemeClr val="accent6">
+                    <a:lumMod val="75000"/>
+                  </a:schemeClr>
+                </a:solidFill>
+                <a:latin typeface="Courier New" panose="02070309020205020404" pitchFamily="49" charset="0"/>
+              </a:rPr>
+              <a:t>if (</a:t>
+            </a:r>
+            <a:r>
+              <a:rPr lang="en-US" sz="2400" dirty="0" err="1">
+                <a:solidFill>
+                  <a:schemeClr val="accent6">
+                    <a:lumMod val="75000"/>
+                  </a:schemeClr>
+                </a:solidFill>
+                <a:latin typeface="Courier New" panose="02070309020205020404" pitchFamily="49" charset="0"/>
+              </a:rPr>
+              <a:t>pairs.containsKey</a:t>
+            </a:r>
+            <a:r>
+              <a:rPr lang="en-US" sz="2400" dirty="0">
+                <a:solidFill>
+                  <a:schemeClr val="accent6">
+                    <a:lumMod val="75000"/>
+                  </a:schemeClr>
+                </a:solidFill>
+                <a:latin typeface="Courier New" panose="02070309020205020404" pitchFamily="49" charset="0"/>
+              </a:rPr>
+              <a:t>(</a:t>
+            </a:r>
+            <a:r>
+              <a:rPr lang="en-US" sz="2400" dirty="0" err="1">
+                <a:solidFill>
+                  <a:schemeClr val="accent6">
+                    <a:lumMod val="75000"/>
+                  </a:schemeClr>
+                </a:solidFill>
+                <a:latin typeface="Courier New" panose="02070309020205020404" pitchFamily="49" charset="0"/>
+              </a:rPr>
+              <a:t>curr</a:t>
+            </a:r>
+            <a:r>
+              <a:rPr lang="en-US" sz="2400" dirty="0">
+                <a:solidFill>
+                  <a:schemeClr val="accent6">
+                    <a:lumMod val="75000"/>
+                  </a:schemeClr>
+                </a:solidFill>
+                <a:latin typeface="Courier New" panose="02070309020205020404" pitchFamily="49" charset="0"/>
+              </a:rPr>
+              <a:t>))</a:t>
+            </a:r>
+            <a:br>
+              <a:rPr lang="en-US" sz="2400" dirty="0">
+                <a:solidFill>
+                  <a:schemeClr val="accent6">
+                    <a:lumMod val="75000"/>
+                  </a:schemeClr>
+                </a:solidFill>
+                <a:latin typeface="Courier New" panose="02070309020205020404" pitchFamily="49" charset="0"/>
+              </a:rPr>
+            </a:br>
+            <a:r>
+              <a:rPr lang="en-US" sz="1800" dirty="0">
+                <a:solidFill>
+                  <a:schemeClr val="accent6">
+                    <a:lumMod val="75000"/>
+                  </a:schemeClr>
+                </a:solidFill>
+                <a:latin typeface="Courier New" panose="02070309020205020404" pitchFamily="49" charset="0"/>
+              </a:rPr>
+              <a:t>      </a:t>
+            </a:r>
+          </a:p>
+          <a:p>
+            <a:r>
+              <a:rPr lang="en-US" sz="2400" dirty="0">
+                <a:solidFill>
+                  <a:srgbClr val="000000"/>
+                </a:solidFill>
+                <a:latin typeface="Abadi" panose="020B0604020104020204" pitchFamily="34" charset="0"/>
+              </a:rPr>
+              <a:t>Check to see if current character is an closed symbol: </a:t>
+            </a:r>
+          </a:p>
+          <a:p>
+            <a:pPr algn="ctr">
+              <a:lnSpc>
+                <a:spcPct val="150000"/>
+              </a:lnSpc>
+            </a:pPr>
+            <a:r>
+              <a:rPr lang="en-US" sz="2400" dirty="0">
+                <a:solidFill>
+                  <a:schemeClr val="accent6">
+                    <a:lumMod val="75000"/>
+                  </a:schemeClr>
+                </a:solidFill>
+                <a:latin typeface="Courier New" panose="02070309020205020404" pitchFamily="49" charset="0"/>
+              </a:rPr>
+              <a:t>if (</a:t>
+            </a:r>
+            <a:r>
+              <a:rPr lang="en-US" sz="2400" dirty="0" err="1">
+                <a:solidFill>
+                  <a:schemeClr val="accent6">
+                    <a:lumMod val="75000"/>
+                  </a:schemeClr>
+                </a:solidFill>
+                <a:latin typeface="Courier New" panose="02070309020205020404" pitchFamily="49" charset="0"/>
+              </a:rPr>
+              <a:t>pairs.containsValue</a:t>
+            </a:r>
+            <a:r>
+              <a:rPr lang="en-US" sz="2400" dirty="0">
+                <a:solidFill>
+                  <a:schemeClr val="accent6">
+                    <a:lumMod val="75000"/>
+                  </a:schemeClr>
+                </a:solidFill>
+                <a:latin typeface="Courier New" panose="02070309020205020404" pitchFamily="49" charset="0"/>
+              </a:rPr>
+              <a:t>(</a:t>
+            </a:r>
+            <a:r>
+              <a:rPr lang="en-US" sz="2400" dirty="0" err="1">
+                <a:solidFill>
+                  <a:schemeClr val="accent6">
+                    <a:lumMod val="75000"/>
+                  </a:schemeClr>
+                </a:solidFill>
+                <a:latin typeface="Courier New" panose="02070309020205020404" pitchFamily="49" charset="0"/>
+              </a:rPr>
+              <a:t>curr</a:t>
+            </a:r>
+            <a:r>
+              <a:rPr lang="en-US" sz="2400" dirty="0">
+                <a:solidFill>
+                  <a:schemeClr val="accent6">
+                    <a:lumMod val="75000"/>
+                  </a:schemeClr>
+                </a:solidFill>
+                <a:latin typeface="Courier New" panose="02070309020205020404" pitchFamily="49" charset="0"/>
+              </a:rPr>
+              <a:t>))</a:t>
+            </a:r>
+          </a:p>
+        </p:txBody>
+      </p:sp>
     </p:spTree>
     <p:extLst>
       <p:ext uri="{BB962C8B-B14F-4D97-AF65-F5344CB8AC3E}">
         <p14:creationId xmlns:p14="http://schemas.microsoft.com/office/powerpoint/2010/main" val="1062535857"/>
+      </p:ext>
+    </p:extLst>
+  </p:cSld>
+  <p:clrMapOvr>
+    <a:masterClrMapping/>
+  </p:clrMapOvr>
+</p:sld>
+</file>
+
+<file path=ppt/slides/slide17.xml><?xml version="1.0" encoding="utf-8"?>
+<p:sld xmlns:a="http://schemas.openxmlformats.org/drawingml/2006/main" xmlns:r="http://schemas.openxmlformats.org/officeDocument/2006/relationships" xmlns:p="http://schemas.openxmlformats.org/presentationml/2006/main">
+  <p:cSld>
+    <p:spTree>
+      <p:nvGrpSpPr>
+        <p:cNvPr id="1" name="">
+          <a:extLst>
+            <a:ext uri="{FF2B5EF4-FFF2-40B4-BE49-F238E27FC236}">
+              <a16:creationId xmlns:a16="http://schemas.microsoft.com/office/drawing/2014/main" id="{A78E0A8C-218A-EDB5-B8F2-8DE90A4A6978}"/>
+            </a:ext>
+          </a:extLst>
+        </p:cNvPr>
+        <p:cNvGrpSpPr/>
+        <p:nvPr/>
+      </p:nvGrpSpPr>
+      <p:grpSpPr>
+        <a:xfrm>
+          <a:off x="0" y="0"/>
+          <a:ext cx="0" cy="0"/>
+          <a:chOff x="0" y="0"/>
+          <a:chExt cx="0" cy="0"/>
+        </a:xfrm>
+      </p:grpSpPr>
+      <p:sp>
+        <p:nvSpPr>
+          <p:cNvPr id="6" name="TextBox 5">
+            <a:extLst>
+              <a:ext uri="{FF2B5EF4-FFF2-40B4-BE49-F238E27FC236}">
+                <a16:creationId xmlns:a16="http://schemas.microsoft.com/office/drawing/2014/main" id="{FB7F221E-AFD4-CDDB-6682-031F7E424B49}"/>
+              </a:ext>
+            </a:extLst>
+          </p:cNvPr>
+          <p:cNvSpPr txBox="1"/>
+          <p:nvPr/>
+        </p:nvSpPr>
+        <p:spPr>
+          <a:xfrm>
+            <a:off x="266700" y="1143000"/>
+            <a:ext cx="8610600" cy="2677656"/>
+          </a:xfrm>
+          <a:prstGeom prst="rect">
+            <a:avLst/>
+          </a:prstGeom>
+          <a:noFill/>
+        </p:spPr>
+        <p:txBody>
+          <a:bodyPr wrap="square">
+            <a:spAutoFit/>
+          </a:bodyPr>
+          <a:lstStyle/>
+          <a:p>
+            <a:r>
+              <a:rPr lang="en-US" sz="2400" dirty="0">
+                <a:latin typeface="Courier New" panose="02070309020205020404" pitchFamily="49" charset="0"/>
+              </a:rPr>
+              <a:t>public </a:t>
+            </a:r>
+            <a:r>
+              <a:rPr lang="en-US" sz="2400" dirty="0" err="1">
+                <a:latin typeface="Courier New" panose="02070309020205020404" pitchFamily="49" charset="0"/>
+              </a:rPr>
+              <a:t>boolean</a:t>
+            </a:r>
+            <a:r>
+              <a:rPr lang="en-US" sz="2400" dirty="0">
+                <a:latin typeface="Courier New" panose="02070309020205020404" pitchFamily="49" charset="0"/>
+              </a:rPr>
+              <a:t> </a:t>
+            </a:r>
+            <a:r>
+              <a:rPr lang="en-US" sz="2400" dirty="0" err="1">
+                <a:latin typeface="Courier New" panose="02070309020205020404" pitchFamily="49" charset="0"/>
+              </a:rPr>
+              <a:t>checkExpression</a:t>
+            </a:r>
+            <a:r>
+              <a:rPr lang="en-US" sz="2400" dirty="0">
+                <a:latin typeface="Courier New" panose="02070309020205020404" pitchFamily="49" charset="0"/>
+              </a:rPr>
+              <a:t>() {</a:t>
+            </a:r>
+            <a:br>
+              <a:rPr lang="en-US" sz="2400" dirty="0">
+                <a:latin typeface="Courier New" panose="02070309020205020404" pitchFamily="49" charset="0"/>
+              </a:rPr>
+            </a:br>
+            <a:r>
+              <a:rPr lang="en-US" sz="2400" dirty="0">
+                <a:latin typeface="Courier New" panose="02070309020205020404" pitchFamily="49" charset="0"/>
+              </a:rPr>
+              <a:t>   Stack&lt;String&gt; stack = new Stack&lt;&gt;();</a:t>
+            </a:r>
+            <a:br>
+              <a:rPr lang="en-US" sz="2400" dirty="0">
+                <a:solidFill>
+                  <a:srgbClr val="000000"/>
+                </a:solidFill>
+                <a:latin typeface="Courier New" panose="02070309020205020404" pitchFamily="49" charset="0"/>
+              </a:rPr>
+            </a:br>
+            <a:r>
+              <a:rPr lang="en-US" sz="2400" dirty="0">
+                <a:solidFill>
+                  <a:srgbClr val="000000"/>
+                </a:solidFill>
+                <a:latin typeface="Courier New" panose="02070309020205020404" pitchFamily="49" charset="0"/>
+              </a:rPr>
+              <a:t>   </a:t>
+            </a:r>
+            <a:r>
+              <a:rPr lang="en-US" sz="2400" dirty="0">
+                <a:solidFill>
+                  <a:schemeClr val="accent6">
+                    <a:lumMod val="75000"/>
+                  </a:schemeClr>
+                </a:solidFill>
+                <a:latin typeface="Courier New" panose="02070309020205020404" pitchFamily="49" charset="0"/>
+              </a:rPr>
+              <a:t>Map&lt;</a:t>
+            </a:r>
+            <a:r>
+              <a:rPr lang="en-US" sz="2400" dirty="0" err="1">
+                <a:solidFill>
+                  <a:schemeClr val="accent6">
+                    <a:lumMod val="75000"/>
+                  </a:schemeClr>
+                </a:solidFill>
+                <a:latin typeface="Courier New" panose="02070309020205020404" pitchFamily="49" charset="0"/>
+              </a:rPr>
+              <a:t>String,String</a:t>
+            </a:r>
+            <a:r>
+              <a:rPr lang="en-US" sz="2400" dirty="0">
+                <a:solidFill>
+                  <a:schemeClr val="accent6">
+                    <a:lumMod val="75000"/>
+                  </a:schemeClr>
+                </a:solidFill>
+                <a:latin typeface="Courier New" panose="02070309020205020404" pitchFamily="49" charset="0"/>
+              </a:rPr>
+              <a:t>&gt; pairs = new HashMap&lt;&gt;();</a:t>
+            </a:r>
+            <a:br>
+              <a:rPr lang="en-US" sz="2400" dirty="0">
+                <a:solidFill>
+                  <a:schemeClr val="accent6">
+                    <a:lumMod val="75000"/>
+                  </a:schemeClr>
+                </a:solidFill>
+                <a:latin typeface="Courier New" panose="02070309020205020404" pitchFamily="49" charset="0"/>
+              </a:rPr>
+            </a:br>
+            <a:r>
+              <a:rPr lang="en-US" sz="2400" dirty="0">
+                <a:solidFill>
+                  <a:schemeClr val="accent6">
+                    <a:lumMod val="75000"/>
+                  </a:schemeClr>
+                </a:solidFill>
+                <a:latin typeface="Courier New" panose="02070309020205020404" pitchFamily="49" charset="0"/>
+              </a:rPr>
+              <a:t>   </a:t>
+            </a:r>
+            <a:r>
+              <a:rPr lang="en-US" sz="2400" dirty="0" err="1">
+                <a:solidFill>
+                  <a:schemeClr val="accent6">
+                    <a:lumMod val="75000"/>
+                  </a:schemeClr>
+                </a:solidFill>
+                <a:latin typeface="Courier New" panose="02070309020205020404" pitchFamily="49" charset="0"/>
+              </a:rPr>
+              <a:t>pairs.put</a:t>
+            </a:r>
+            <a:r>
+              <a:rPr lang="en-US" sz="2400" dirty="0">
+                <a:solidFill>
+                  <a:schemeClr val="accent6">
+                    <a:lumMod val="75000"/>
+                  </a:schemeClr>
+                </a:solidFill>
+                <a:latin typeface="Courier New" panose="02070309020205020404" pitchFamily="49" charset="0"/>
+              </a:rPr>
+              <a:t>(</a:t>
+            </a:r>
+            <a:r>
+              <a:rPr lang="en-US" sz="2400" dirty="0">
+                <a:solidFill>
+                  <a:srgbClr val="00A000"/>
+                </a:solidFill>
+                <a:latin typeface="Courier New" panose="02070309020205020404" pitchFamily="49" charset="0"/>
+              </a:rPr>
+              <a:t>"{"</a:t>
+            </a:r>
+            <a:r>
+              <a:rPr lang="en-US" sz="2400" dirty="0">
+                <a:solidFill>
+                  <a:srgbClr val="000000"/>
+                </a:solidFill>
+                <a:latin typeface="Courier New" panose="02070309020205020404" pitchFamily="49" charset="0"/>
+              </a:rPr>
+              <a:t>, </a:t>
+            </a:r>
+            <a:r>
+              <a:rPr lang="en-US" sz="2400" dirty="0">
+                <a:solidFill>
+                  <a:srgbClr val="00A000"/>
+                </a:solidFill>
+                <a:latin typeface="Courier New" panose="02070309020205020404" pitchFamily="49" charset="0"/>
+              </a:rPr>
+              <a:t>"}"</a:t>
+            </a:r>
+            <a:r>
+              <a:rPr lang="en-US" sz="2400" dirty="0">
+                <a:solidFill>
+                  <a:schemeClr val="accent6">
+                    <a:lumMod val="75000"/>
+                  </a:schemeClr>
+                </a:solidFill>
+                <a:latin typeface="Courier New" panose="02070309020205020404" pitchFamily="49" charset="0"/>
+              </a:rPr>
+              <a:t>)</a:t>
+            </a:r>
+            <a:r>
+              <a:rPr lang="en-US" sz="2400" dirty="0">
+                <a:solidFill>
+                  <a:srgbClr val="000000"/>
+                </a:solidFill>
+                <a:latin typeface="Courier New" panose="02070309020205020404" pitchFamily="49" charset="0"/>
+              </a:rPr>
+              <a:t>;</a:t>
+            </a:r>
+            <a:br>
+              <a:rPr lang="en-US" sz="2400" dirty="0">
+                <a:solidFill>
+                  <a:srgbClr val="000000"/>
+                </a:solidFill>
+                <a:latin typeface="Courier New" panose="02070309020205020404" pitchFamily="49" charset="0"/>
+              </a:rPr>
+            </a:br>
+            <a:r>
+              <a:rPr lang="en-US" sz="2400" dirty="0">
+                <a:solidFill>
+                  <a:srgbClr val="000000"/>
+                </a:solidFill>
+                <a:latin typeface="Courier New" panose="02070309020205020404" pitchFamily="49" charset="0"/>
+              </a:rPr>
+              <a:t>   </a:t>
+            </a:r>
+            <a:r>
+              <a:rPr lang="en-US" sz="2400" dirty="0" err="1">
+                <a:solidFill>
+                  <a:schemeClr val="accent6">
+                    <a:lumMod val="75000"/>
+                  </a:schemeClr>
+                </a:solidFill>
+                <a:latin typeface="Courier New" panose="02070309020205020404" pitchFamily="49" charset="0"/>
+              </a:rPr>
+              <a:t>pairs.put</a:t>
+            </a:r>
+            <a:r>
+              <a:rPr lang="en-US" sz="2400" dirty="0">
+                <a:solidFill>
+                  <a:schemeClr val="accent6">
+                    <a:lumMod val="75000"/>
+                  </a:schemeClr>
+                </a:solidFill>
+                <a:latin typeface="Courier New" panose="02070309020205020404" pitchFamily="49" charset="0"/>
+              </a:rPr>
+              <a:t>(</a:t>
+            </a:r>
+            <a:r>
+              <a:rPr lang="en-US" sz="2400" dirty="0">
+                <a:solidFill>
+                  <a:srgbClr val="00A000"/>
+                </a:solidFill>
+                <a:latin typeface="Courier New" panose="02070309020205020404" pitchFamily="49" charset="0"/>
+              </a:rPr>
+              <a:t>"("</a:t>
+            </a:r>
+            <a:r>
+              <a:rPr lang="en-US" sz="2400" dirty="0">
+                <a:solidFill>
+                  <a:srgbClr val="000000"/>
+                </a:solidFill>
+                <a:latin typeface="Courier New" panose="02070309020205020404" pitchFamily="49" charset="0"/>
+              </a:rPr>
+              <a:t>, </a:t>
+            </a:r>
+            <a:r>
+              <a:rPr lang="en-US" sz="2400" dirty="0">
+                <a:solidFill>
+                  <a:srgbClr val="00A000"/>
+                </a:solidFill>
+                <a:latin typeface="Courier New" panose="02070309020205020404" pitchFamily="49" charset="0"/>
+              </a:rPr>
+              <a:t>")"</a:t>
+            </a:r>
+            <a:r>
+              <a:rPr lang="en-US" sz="2400" dirty="0">
+                <a:solidFill>
+                  <a:schemeClr val="accent6">
+                    <a:lumMod val="75000"/>
+                  </a:schemeClr>
+                </a:solidFill>
+                <a:latin typeface="Courier New" panose="02070309020205020404" pitchFamily="49" charset="0"/>
+              </a:rPr>
+              <a:t>)</a:t>
+            </a:r>
+            <a:r>
+              <a:rPr lang="en-US" sz="2400" dirty="0">
+                <a:solidFill>
+                  <a:srgbClr val="000000"/>
+                </a:solidFill>
+                <a:latin typeface="Courier New" panose="02070309020205020404" pitchFamily="49" charset="0"/>
+              </a:rPr>
+              <a:t>;</a:t>
+            </a:r>
+            <a:br>
+              <a:rPr lang="en-US" sz="2400" dirty="0">
+                <a:solidFill>
+                  <a:srgbClr val="000000"/>
+                </a:solidFill>
+                <a:latin typeface="Courier New" panose="02070309020205020404" pitchFamily="49" charset="0"/>
+              </a:rPr>
+            </a:br>
+            <a:r>
+              <a:rPr lang="en-US" sz="2400" dirty="0">
+                <a:solidFill>
+                  <a:srgbClr val="000000"/>
+                </a:solidFill>
+                <a:latin typeface="Courier New" panose="02070309020205020404" pitchFamily="49" charset="0"/>
+              </a:rPr>
+              <a:t>   </a:t>
+            </a:r>
+            <a:r>
+              <a:rPr lang="en-US" sz="2400" dirty="0" err="1">
+                <a:solidFill>
+                  <a:schemeClr val="accent6">
+                    <a:lumMod val="75000"/>
+                  </a:schemeClr>
+                </a:solidFill>
+                <a:latin typeface="Courier New" panose="02070309020205020404" pitchFamily="49" charset="0"/>
+              </a:rPr>
+              <a:t>pairs.put</a:t>
+            </a:r>
+            <a:r>
+              <a:rPr lang="en-US" sz="2400" dirty="0">
+                <a:solidFill>
+                  <a:schemeClr val="accent6">
+                    <a:lumMod val="75000"/>
+                  </a:schemeClr>
+                </a:solidFill>
+                <a:latin typeface="Courier New" panose="02070309020205020404" pitchFamily="49" charset="0"/>
+              </a:rPr>
+              <a:t>(</a:t>
+            </a:r>
+            <a:r>
+              <a:rPr lang="en-US" sz="2400" dirty="0">
+                <a:solidFill>
+                  <a:srgbClr val="00A000"/>
+                </a:solidFill>
+                <a:latin typeface="Courier New" panose="02070309020205020404" pitchFamily="49" charset="0"/>
+              </a:rPr>
+              <a:t>"&lt;"</a:t>
+            </a:r>
+            <a:r>
+              <a:rPr lang="en-US" sz="2400" dirty="0">
+                <a:solidFill>
+                  <a:srgbClr val="000000"/>
+                </a:solidFill>
+                <a:latin typeface="Courier New" panose="02070309020205020404" pitchFamily="49" charset="0"/>
+              </a:rPr>
+              <a:t>, </a:t>
+            </a:r>
+            <a:r>
+              <a:rPr lang="en-US" sz="2400" dirty="0">
+                <a:solidFill>
+                  <a:srgbClr val="00A000"/>
+                </a:solidFill>
+                <a:latin typeface="Courier New" panose="02070309020205020404" pitchFamily="49" charset="0"/>
+              </a:rPr>
+              <a:t>"&gt;"</a:t>
+            </a:r>
+            <a:r>
+              <a:rPr lang="en-US" sz="2400" dirty="0">
+                <a:solidFill>
+                  <a:schemeClr val="accent6">
+                    <a:lumMod val="75000"/>
+                  </a:schemeClr>
+                </a:solidFill>
+                <a:latin typeface="Courier New" panose="02070309020205020404" pitchFamily="49" charset="0"/>
+              </a:rPr>
+              <a:t>)</a:t>
+            </a:r>
+            <a:r>
+              <a:rPr lang="en-US" sz="2400" dirty="0">
+                <a:solidFill>
+                  <a:srgbClr val="000000"/>
+                </a:solidFill>
+                <a:latin typeface="Courier New" panose="02070309020205020404" pitchFamily="49" charset="0"/>
+              </a:rPr>
+              <a:t>;</a:t>
+            </a:r>
+            <a:br>
+              <a:rPr lang="en-US" sz="2400" dirty="0">
+                <a:solidFill>
+                  <a:srgbClr val="000000"/>
+                </a:solidFill>
+                <a:latin typeface="Courier New" panose="02070309020205020404" pitchFamily="49" charset="0"/>
+              </a:rPr>
+            </a:br>
+            <a:r>
+              <a:rPr lang="en-US" sz="2400" dirty="0">
+                <a:solidFill>
+                  <a:srgbClr val="000000"/>
+                </a:solidFill>
+                <a:latin typeface="Courier New" panose="02070309020205020404" pitchFamily="49" charset="0"/>
+              </a:rPr>
+              <a:t>   </a:t>
+            </a:r>
+            <a:r>
+              <a:rPr lang="en-US" sz="2400" dirty="0" err="1">
+                <a:solidFill>
+                  <a:schemeClr val="accent6">
+                    <a:lumMod val="75000"/>
+                  </a:schemeClr>
+                </a:solidFill>
+                <a:latin typeface="Courier New" panose="02070309020205020404" pitchFamily="49" charset="0"/>
+              </a:rPr>
+              <a:t>pairs.put</a:t>
+            </a:r>
+            <a:r>
+              <a:rPr lang="en-US" sz="2400" dirty="0">
+                <a:solidFill>
+                  <a:schemeClr val="accent6">
+                    <a:lumMod val="75000"/>
+                  </a:schemeClr>
+                </a:solidFill>
+                <a:latin typeface="Courier New" panose="02070309020205020404" pitchFamily="49" charset="0"/>
+              </a:rPr>
+              <a:t>(</a:t>
+            </a:r>
+            <a:r>
+              <a:rPr lang="en-US" sz="2400" dirty="0">
+                <a:solidFill>
+                  <a:srgbClr val="00A000"/>
+                </a:solidFill>
+                <a:latin typeface="Courier New" panose="02070309020205020404" pitchFamily="49" charset="0"/>
+              </a:rPr>
+              <a:t>"["</a:t>
+            </a:r>
+            <a:r>
+              <a:rPr lang="en-US" sz="2400" dirty="0">
+                <a:solidFill>
+                  <a:srgbClr val="000000"/>
+                </a:solidFill>
+                <a:latin typeface="Courier New" panose="02070309020205020404" pitchFamily="49" charset="0"/>
+              </a:rPr>
+              <a:t>, </a:t>
+            </a:r>
+            <a:r>
+              <a:rPr lang="en-US" sz="2400" dirty="0">
+                <a:solidFill>
+                  <a:srgbClr val="00A000"/>
+                </a:solidFill>
+                <a:latin typeface="Courier New" panose="02070309020205020404" pitchFamily="49" charset="0"/>
+              </a:rPr>
+              <a:t>"]"</a:t>
+            </a:r>
+            <a:r>
+              <a:rPr lang="en-US" sz="2400" dirty="0">
+                <a:solidFill>
+                  <a:schemeClr val="accent6">
+                    <a:lumMod val="75000"/>
+                  </a:schemeClr>
+                </a:solidFill>
+                <a:latin typeface="Courier New" panose="02070309020205020404" pitchFamily="49" charset="0"/>
+              </a:rPr>
+              <a:t>)</a:t>
+            </a:r>
+            <a:r>
+              <a:rPr lang="en-US" sz="2400" dirty="0">
+                <a:solidFill>
+                  <a:srgbClr val="000000"/>
+                </a:solidFill>
+                <a:latin typeface="Courier New" panose="02070309020205020404" pitchFamily="49" charset="0"/>
+              </a:rPr>
+              <a:t>;</a:t>
+            </a:r>
+            <a:endParaRPr lang="en-US" sz="2400" dirty="0"/>
+          </a:p>
+        </p:txBody>
+      </p:sp>
+      <p:sp>
+        <p:nvSpPr>
+          <p:cNvPr id="5" name="Title 1">
+            <a:extLst>
+              <a:ext uri="{FF2B5EF4-FFF2-40B4-BE49-F238E27FC236}">
+                <a16:creationId xmlns:a16="http://schemas.microsoft.com/office/drawing/2014/main" id="{5AD3EF66-1A07-CD63-A6A8-0D202DB3455D}"/>
+              </a:ext>
+            </a:extLst>
+          </p:cNvPr>
+          <p:cNvSpPr txBox="1">
+            <a:spLocks/>
+          </p:cNvSpPr>
+          <p:nvPr/>
+        </p:nvSpPr>
+        <p:spPr bwMode="auto">
+          <a:xfrm>
+            <a:off x="76200" y="152401"/>
+            <a:ext cx="8915400" cy="685800"/>
+          </a:xfrm>
+          <a:prstGeom prst="rect">
+            <a:avLst/>
+          </a:prstGeom>
+          <a:noFill/>
+          <a:ln>
+            <a:noFill/>
+          </a:ln>
+          <a:effectLst/>
+          <a:extLst>
+            <a:ext uri="{909E8E84-426E-40DD-AFC4-6F175D3DCCD1}">
+              <a14:hiddenFill xmlns:a14="http://schemas.microsoft.com/office/drawing/2010/main">
+                <a:solidFill>
+                  <a:schemeClr val="accent1"/>
+                </a:solidFill>
+              </a14:hiddenFill>
+            </a:ext>
+            <a:ext uri="{91240B29-F687-4F45-9708-019B960494DF}">
+              <a14:hiddenLine xmlns:a14="http://schemas.microsoft.com/office/drawing/2010/main" w="9525">
+                <a:solidFill>
+                  <a:schemeClr val="tx1"/>
+                </a:solidFill>
+                <a:miter lim="800000"/>
+                <a:headEnd/>
+                <a:tailEnd/>
+              </a14:hiddenLine>
+            </a:ext>
+            <a:ext uri="{AF507438-7753-43E0-B8FC-AC1667EBCBE1}">
+              <a14:hiddenEffects xmlns:a14="http://schemas.microsoft.com/office/drawing/2010/main">
+                <a:effectLst>
+                  <a:outerShdw dist="35921" dir="2700000" algn="ctr" rotWithShape="0">
+                    <a:schemeClr val="bg2"/>
+                  </a:outerShdw>
+                </a:effectLst>
+              </a14:hiddenEffects>
+            </a:ext>
+          </a:extLst>
+        </p:spPr>
+        <p:txBody>
+          <a:bodyPr vert="horz" wrap="square" lIns="92075" tIns="46038" rIns="92075" bIns="46038" numCol="1" anchor="ctr" anchorCtr="0" compatLnSpc="1">
+            <a:prstTxWarp prst="textNoShape">
+              <a:avLst/>
+            </a:prstTxWarp>
+          </a:bodyPr>
+          <a:lstStyle>
+            <a:lvl1pPr algn="ctr" rtl="0" eaLnBrk="0" fontAlgn="base" hangingPunct="0">
+              <a:spcBef>
+                <a:spcPct val="0"/>
+              </a:spcBef>
+              <a:spcAft>
+                <a:spcPct val="0"/>
+              </a:spcAft>
+              <a:defRPr sz="4400">
+                <a:solidFill>
+                  <a:schemeClr val="tx2"/>
+                </a:solidFill>
+                <a:latin typeface="+mj-lt"/>
+                <a:ea typeface="+mj-ea"/>
+                <a:cs typeface="+mj-cs"/>
+              </a:defRPr>
+            </a:lvl1pPr>
+            <a:lvl2pPr algn="ctr" rtl="0" eaLnBrk="0" fontAlgn="base" hangingPunct="0">
+              <a:spcBef>
+                <a:spcPct val="0"/>
+              </a:spcBef>
+              <a:spcAft>
+                <a:spcPct val="0"/>
+              </a:spcAft>
+              <a:defRPr sz="4400">
+                <a:solidFill>
+                  <a:schemeClr val="tx2"/>
+                </a:solidFill>
+                <a:latin typeface="Times New Roman" pitchFamily="18" charset="0"/>
+              </a:defRPr>
+            </a:lvl2pPr>
+            <a:lvl3pPr algn="ctr" rtl="0" eaLnBrk="0" fontAlgn="base" hangingPunct="0">
+              <a:spcBef>
+                <a:spcPct val="0"/>
+              </a:spcBef>
+              <a:spcAft>
+                <a:spcPct val="0"/>
+              </a:spcAft>
+              <a:defRPr sz="4400">
+                <a:solidFill>
+                  <a:schemeClr val="tx2"/>
+                </a:solidFill>
+                <a:latin typeface="Times New Roman" pitchFamily="18" charset="0"/>
+              </a:defRPr>
+            </a:lvl3pPr>
+            <a:lvl4pPr algn="ctr" rtl="0" eaLnBrk="0" fontAlgn="base" hangingPunct="0">
+              <a:spcBef>
+                <a:spcPct val="0"/>
+              </a:spcBef>
+              <a:spcAft>
+                <a:spcPct val="0"/>
+              </a:spcAft>
+              <a:defRPr sz="4400">
+                <a:solidFill>
+                  <a:schemeClr val="tx2"/>
+                </a:solidFill>
+                <a:latin typeface="Times New Roman" pitchFamily="18" charset="0"/>
+              </a:defRPr>
+            </a:lvl4pPr>
+            <a:lvl5pPr algn="ctr" rtl="0" eaLnBrk="0" fontAlgn="base" hangingPunct="0">
+              <a:spcBef>
+                <a:spcPct val="0"/>
+              </a:spcBef>
+              <a:spcAft>
+                <a:spcPct val="0"/>
+              </a:spcAft>
+              <a:defRPr sz="4400">
+                <a:solidFill>
+                  <a:schemeClr val="tx2"/>
+                </a:solidFill>
+                <a:latin typeface="Times New Roman" pitchFamily="18" charset="0"/>
+              </a:defRPr>
+            </a:lvl5pPr>
+            <a:lvl6pPr marL="457200" algn="ctr" rtl="0" fontAlgn="base">
+              <a:spcBef>
+                <a:spcPct val="0"/>
+              </a:spcBef>
+              <a:spcAft>
+                <a:spcPct val="0"/>
+              </a:spcAft>
+              <a:defRPr sz="4400">
+                <a:solidFill>
+                  <a:schemeClr val="tx2"/>
+                </a:solidFill>
+                <a:latin typeface="Times New Roman" pitchFamily="18" charset="0"/>
+              </a:defRPr>
+            </a:lvl6pPr>
+            <a:lvl7pPr marL="914400" algn="ctr" rtl="0" fontAlgn="base">
+              <a:spcBef>
+                <a:spcPct val="0"/>
+              </a:spcBef>
+              <a:spcAft>
+                <a:spcPct val="0"/>
+              </a:spcAft>
+              <a:defRPr sz="4400">
+                <a:solidFill>
+                  <a:schemeClr val="tx2"/>
+                </a:solidFill>
+                <a:latin typeface="Times New Roman" pitchFamily="18" charset="0"/>
+              </a:defRPr>
+            </a:lvl7pPr>
+            <a:lvl8pPr marL="1371600" algn="ctr" rtl="0" fontAlgn="base">
+              <a:spcBef>
+                <a:spcPct val="0"/>
+              </a:spcBef>
+              <a:spcAft>
+                <a:spcPct val="0"/>
+              </a:spcAft>
+              <a:defRPr sz="4400">
+                <a:solidFill>
+                  <a:schemeClr val="tx2"/>
+                </a:solidFill>
+                <a:latin typeface="Times New Roman" pitchFamily="18" charset="0"/>
+              </a:defRPr>
+            </a:lvl8pPr>
+            <a:lvl9pPr marL="1828800" algn="ctr" rtl="0" fontAlgn="base">
+              <a:spcBef>
+                <a:spcPct val="0"/>
+              </a:spcBef>
+              <a:spcAft>
+                <a:spcPct val="0"/>
+              </a:spcAft>
+              <a:defRPr sz="4400">
+                <a:solidFill>
+                  <a:schemeClr val="tx2"/>
+                </a:solidFill>
+                <a:latin typeface="Times New Roman" pitchFamily="18" charset="0"/>
+              </a:defRPr>
+            </a:lvl9pPr>
+          </a:lstStyle>
+          <a:p>
+            <a:r>
+              <a:rPr lang="en-US" b="0" kern="0" dirty="0">
+                <a:solidFill>
+                  <a:srgbClr val="7030A0"/>
+                </a:solidFill>
+                <a:latin typeface="Abadi" panose="020B0604020104020204" pitchFamily="34" charset="0"/>
+              </a:rPr>
+              <a:t>Matching Symbols using </a:t>
+            </a:r>
+            <a:r>
+              <a:rPr lang="en-US" b="0" kern="0" dirty="0">
+                <a:solidFill>
+                  <a:srgbClr val="00B050"/>
+                </a:solidFill>
+                <a:latin typeface="Abadi" panose="020B0604020104020204" pitchFamily="34" charset="0"/>
+              </a:rPr>
+              <a:t>a Map</a:t>
+            </a:r>
+          </a:p>
+        </p:txBody>
+      </p:sp>
+      <p:sp>
+        <p:nvSpPr>
+          <p:cNvPr id="2" name="TextBox 1">
+            <a:extLst>
+              <a:ext uri="{FF2B5EF4-FFF2-40B4-BE49-F238E27FC236}">
+                <a16:creationId xmlns:a16="http://schemas.microsoft.com/office/drawing/2014/main" id="{5880B75C-692E-72D9-A6D4-956A41C16D96}"/>
+              </a:ext>
+            </a:extLst>
+          </p:cNvPr>
+          <p:cNvSpPr txBox="1"/>
+          <p:nvPr/>
+        </p:nvSpPr>
+        <p:spPr>
+          <a:xfrm>
+            <a:off x="0" y="4139133"/>
+            <a:ext cx="9144000" cy="1423467"/>
+          </a:xfrm>
+          <a:prstGeom prst="rect">
+            <a:avLst/>
+          </a:prstGeom>
+          <a:noFill/>
+        </p:spPr>
+        <p:txBody>
+          <a:bodyPr wrap="square">
+            <a:spAutoFit/>
+          </a:bodyPr>
+          <a:lstStyle/>
+          <a:p>
+            <a:r>
+              <a:rPr lang="en-US" sz="2400" dirty="0">
+                <a:solidFill>
+                  <a:srgbClr val="000000"/>
+                </a:solidFill>
+                <a:latin typeface="Abadi" panose="020B0604020104020204" pitchFamily="34" charset="0"/>
+              </a:rPr>
+              <a:t>If current character is a closed symbol, check to see if it corresponds to the open symbol from the top of the stack:</a:t>
+            </a:r>
+          </a:p>
+          <a:p>
+            <a:pPr algn="ctr">
+              <a:lnSpc>
+                <a:spcPct val="150000"/>
+              </a:lnSpc>
+            </a:pPr>
+            <a:r>
+              <a:rPr lang="en-US" dirty="0">
+                <a:solidFill>
+                  <a:schemeClr val="accent6">
+                    <a:lumMod val="75000"/>
+                  </a:schemeClr>
+                </a:solidFill>
+                <a:latin typeface="Courier New" panose="02070309020205020404" pitchFamily="49" charset="0"/>
+              </a:rPr>
+              <a:t>!</a:t>
+            </a:r>
+            <a:r>
+              <a:rPr lang="en-US" dirty="0" err="1">
+                <a:solidFill>
+                  <a:schemeClr val="accent6">
+                    <a:lumMod val="75000"/>
+                  </a:schemeClr>
+                </a:solidFill>
+                <a:latin typeface="Courier New" panose="02070309020205020404" pitchFamily="49" charset="0"/>
+              </a:rPr>
+              <a:t>curr.equals</a:t>
+            </a:r>
+            <a:r>
+              <a:rPr lang="en-US" dirty="0">
+                <a:solidFill>
+                  <a:schemeClr val="accent6">
+                    <a:lumMod val="75000"/>
+                  </a:schemeClr>
+                </a:solidFill>
+                <a:latin typeface="Courier New" panose="02070309020205020404" pitchFamily="49" charset="0"/>
+              </a:rPr>
+              <a:t>(</a:t>
+            </a:r>
+            <a:r>
+              <a:rPr lang="en-US" dirty="0" err="1">
+                <a:solidFill>
+                  <a:schemeClr val="accent6">
+                    <a:lumMod val="75000"/>
+                  </a:schemeClr>
+                </a:solidFill>
+                <a:latin typeface="Courier New" panose="02070309020205020404" pitchFamily="49" charset="0"/>
+              </a:rPr>
+              <a:t>pairs.get</a:t>
+            </a:r>
+            <a:r>
+              <a:rPr lang="en-US" dirty="0">
+                <a:solidFill>
+                  <a:schemeClr val="accent6">
+                    <a:lumMod val="75000"/>
+                  </a:schemeClr>
+                </a:solidFill>
+                <a:latin typeface="Courier New" panose="02070309020205020404" pitchFamily="49" charset="0"/>
+              </a:rPr>
+              <a:t>(</a:t>
+            </a:r>
+            <a:r>
+              <a:rPr lang="en-US" dirty="0" err="1">
+                <a:solidFill>
+                  <a:schemeClr val="accent6">
+                    <a:lumMod val="75000"/>
+                  </a:schemeClr>
+                </a:solidFill>
+                <a:latin typeface="Courier New" panose="02070309020205020404" pitchFamily="49" charset="0"/>
+              </a:rPr>
+              <a:t>stack.pop</a:t>
+            </a:r>
+            <a:r>
+              <a:rPr lang="en-US" dirty="0">
+                <a:solidFill>
+                  <a:schemeClr val="accent6">
+                    <a:lumMod val="75000"/>
+                  </a:schemeClr>
+                </a:solidFill>
+                <a:latin typeface="Courier New" panose="02070309020205020404" pitchFamily="49" charset="0"/>
+              </a:rPr>
+              <a:t>()))</a:t>
+            </a:r>
+          </a:p>
+        </p:txBody>
+      </p:sp>
+    </p:spTree>
+    <p:extLst>
+      <p:ext uri="{BB962C8B-B14F-4D97-AF65-F5344CB8AC3E}">
+        <p14:creationId xmlns:p14="http://schemas.microsoft.com/office/powerpoint/2010/main" val="3364841609"/>
       </p:ext>
     </p:extLst>
   </p:cSld>

</xml_diff>